<commit_message>
Clarify investigation actions and present ProofMesh as an evidence rail
</commit_message>
<xml_diff>
--- a/submission/proofmesh-submission.pptx
+++ b/submission/proofmesh-submission.pptx
@@ -2,45 +2,45 @@
 <file path=ppt/presentation.xml><?xml version="1.0" encoding="utf-8"?>
 <p:presentation xmlns:p="http://schemas.openxmlformats.org/presentationml/2006/main" embedTrueTypeFonts="1" saveSubsetFonts="0">
   <p:sldMasterIdLst>
-    <p:sldMasterId xmlns:r="http://schemas.openxmlformats.org/officeDocument/2006/relationships" id="2147483648" r:id="Re4bc1de629de46f8"/>
+    <p:sldMasterId xmlns:r="http://schemas.openxmlformats.org/officeDocument/2006/relationships" id="2147483648" r:id="R4a587691a506493e"/>
   </p:sldMasterIdLst>
   <p:notesMasterIdLst>
-    <p:notesMasterId xmlns:r="http://schemas.openxmlformats.org/officeDocument/2006/relationships" r:id="Rd435430dcdf34d0b"/>
+    <p:notesMasterId xmlns:r="http://schemas.openxmlformats.org/officeDocument/2006/relationships" r:id="R7cbb0ff96142459c"/>
   </p:notesMasterIdLst>
   <p:sldIdLst>
-    <p:sldId xmlns:r="http://schemas.openxmlformats.org/officeDocument/2006/relationships" id="256" r:id="Rbd137b9a09ac438d"/>
-    <p:sldId xmlns:r="http://schemas.openxmlformats.org/officeDocument/2006/relationships" id="257" r:id="R52a45913ed2449d2"/>
-    <p:sldId xmlns:r="http://schemas.openxmlformats.org/officeDocument/2006/relationships" id="258" r:id="Rcb3a967721574235"/>
-    <p:sldId xmlns:r="http://schemas.openxmlformats.org/officeDocument/2006/relationships" id="259" r:id="R3f429bf588e94d00"/>
-    <p:sldId xmlns:r="http://schemas.openxmlformats.org/officeDocument/2006/relationships" id="260" r:id="R572334a3a85a4bb5"/>
-    <p:sldId xmlns:r="http://schemas.openxmlformats.org/officeDocument/2006/relationships" id="261" r:id="Ra4910dd7c73d4aa9"/>
-    <p:sldId xmlns:r="http://schemas.openxmlformats.org/officeDocument/2006/relationships" id="262" r:id="R43293a7345a74eb8"/>
-    <p:sldId xmlns:r="http://schemas.openxmlformats.org/officeDocument/2006/relationships" id="263" r:id="Rf57360fced634fe9"/>
-    <p:sldId xmlns:r="http://schemas.openxmlformats.org/officeDocument/2006/relationships" id="264" r:id="R138a634be06d4499"/>
-    <p:sldId xmlns:r="http://schemas.openxmlformats.org/officeDocument/2006/relationships" id="265" r:id="Rc39020cbc9214746"/>
-    <p:sldId xmlns:r="http://schemas.openxmlformats.org/officeDocument/2006/relationships" id="266" r:id="Rc895dc12c5074e9d"/>
-    <p:sldId xmlns:r="http://schemas.openxmlformats.org/officeDocument/2006/relationships" id="267" r:id="R2506e08e0dcc484e"/>
-    <p:sldId xmlns:r="http://schemas.openxmlformats.org/officeDocument/2006/relationships" id="268" r:id="Rf5a176f90fa74f08"/>
-    <p:sldId xmlns:r="http://schemas.openxmlformats.org/officeDocument/2006/relationships" id="269" r:id="Rbe037342f1504844"/>
-    <p:sldId xmlns:r="http://schemas.openxmlformats.org/officeDocument/2006/relationships" id="270" r:id="Rf70cc3dc25f94bc4"/>
+    <p:sldId xmlns:r="http://schemas.openxmlformats.org/officeDocument/2006/relationships" id="256" r:id="Rba1e49dfa4a74021"/>
+    <p:sldId xmlns:r="http://schemas.openxmlformats.org/officeDocument/2006/relationships" id="257" r:id="R04dea68851ac4e81"/>
+    <p:sldId xmlns:r="http://schemas.openxmlformats.org/officeDocument/2006/relationships" id="258" r:id="Rc9442da4c77f4ce9"/>
+    <p:sldId xmlns:r="http://schemas.openxmlformats.org/officeDocument/2006/relationships" id="259" r:id="Rbd4591e6c72b4d9b"/>
+    <p:sldId xmlns:r="http://schemas.openxmlformats.org/officeDocument/2006/relationships" id="260" r:id="R3aff78f9aff34e25"/>
+    <p:sldId xmlns:r="http://schemas.openxmlformats.org/officeDocument/2006/relationships" id="261" r:id="Rb956b8b2936f413f"/>
+    <p:sldId xmlns:r="http://schemas.openxmlformats.org/officeDocument/2006/relationships" id="262" r:id="Rb28babbb04404004"/>
+    <p:sldId xmlns:r="http://schemas.openxmlformats.org/officeDocument/2006/relationships" id="263" r:id="R3db1934ab7844e34"/>
+    <p:sldId xmlns:r="http://schemas.openxmlformats.org/officeDocument/2006/relationships" id="264" r:id="Ra558ef87c05b47be"/>
+    <p:sldId xmlns:r="http://schemas.openxmlformats.org/officeDocument/2006/relationships" id="265" r:id="R6f12ae3ecd584bf9"/>
+    <p:sldId xmlns:r="http://schemas.openxmlformats.org/officeDocument/2006/relationships" id="266" r:id="R8521e92b96d345d0"/>
+    <p:sldId xmlns:r="http://schemas.openxmlformats.org/officeDocument/2006/relationships" id="267" r:id="R0093384f7a4b4e7e"/>
+    <p:sldId xmlns:r="http://schemas.openxmlformats.org/officeDocument/2006/relationships" id="268" r:id="R9bff6269d9a147ed"/>
+    <p:sldId xmlns:r="http://schemas.openxmlformats.org/officeDocument/2006/relationships" id="269" r:id="R5829e86373e9433b"/>
+    <p:sldId xmlns:r="http://schemas.openxmlformats.org/officeDocument/2006/relationships" id="270" r:id="R553af9082e75475f"/>
   </p:sldIdLst>
   <p:sldSz cx="9144000" cy="5143500"/>
   <p:notesSz cx="6858000" cy="9144000"/>
   <p:embeddedFontLst>
     <p:embeddedFont>
       <p:font typeface="Google Sans Flex Medium"/>
-      <p:regular xmlns:r="http://schemas.openxmlformats.org/officeDocument/2006/relationships" r:id="R49b6a91bb2b046c8"/>
-      <p:bold xmlns:r="http://schemas.openxmlformats.org/officeDocument/2006/relationships" r:id="Rd79294c03eaf4dc1"/>
+      <p:regular xmlns:r="http://schemas.openxmlformats.org/officeDocument/2006/relationships" r:id="R80eebce4e5d440c2"/>
+      <p:bold xmlns:r="http://schemas.openxmlformats.org/officeDocument/2006/relationships" r:id="Rabac75449eb9409c"/>
     </p:embeddedFont>
     <p:embeddedFont>
       <p:font typeface="Google Sans Flex"/>
-      <p:regular xmlns:r="http://schemas.openxmlformats.org/officeDocument/2006/relationships" r:id="R2ea078b8201f4c86"/>
-      <p:bold xmlns:r="http://schemas.openxmlformats.org/officeDocument/2006/relationships" r:id="Rd3637cf6ca1f4db9"/>
+      <p:regular xmlns:r="http://schemas.openxmlformats.org/officeDocument/2006/relationships" r:id="R5bf4229244ed4611"/>
+      <p:bold xmlns:r="http://schemas.openxmlformats.org/officeDocument/2006/relationships" r:id="Ra6f82322f48d4b43"/>
     </p:embeddedFont>
     <p:embeddedFont>
       <p:font typeface="Google Sans Flex SemiBold"/>
-      <p:regular xmlns:r="http://schemas.openxmlformats.org/officeDocument/2006/relationships" r:id="R98d81f1897614e5a"/>
-      <p:bold xmlns:r="http://schemas.openxmlformats.org/officeDocument/2006/relationships" r:id="R1e232f9711f14bbe"/>
+      <p:regular xmlns:r="http://schemas.openxmlformats.org/officeDocument/2006/relationships" r:id="R9c7826d84a64473e"/>
+      <p:bold xmlns:r="http://schemas.openxmlformats.org/officeDocument/2006/relationships" r:id="R04c32cfcf5984e1f"/>
     </p:embeddedFont>
   </p:embeddedFontLst>
   <p:defaultTextStyle>
@@ -735,7 +735,7 @@
               <a:buNone/>
             </a:pPr>
             <a:r>
-              <a:t>ProofMesh / Hounds of Singularity. Sources: repository docs/EVALUATION.md, docs/DEPLOYMENT.md, docs/PRODUCT_QA.md; official AI Builder Cup template preserved. Historical reference: https://science.nasa.gov/resource/apollo-8s-iconic-earthrise/. No claim of NASA endorsement. Working build and measurements verified October 17, 2026.</a:t>
+              <a:t>ProofMesh / Hounds of Singularity. Sources: repository docs/EVALUATION.md, docs/DEPLOYMENT.md, docs/PRODUCT_QA.md, docs/RAIL.md; official AI Builder Cup template preserved. Historical reference: https://science.nasa.gov/resource/apollo-8s-iconic-earthrise/. No claim of NASA endorsement. Working build and measurements verified October 17, 2026.</a:t>
             </a:r>
             <a:endParaRPr/>
           </a:p>
@@ -815,7 +815,7 @@
               <a:buNone/>
             </a:pPr>
             <a:r>
-              <a:t>ProofMesh / Hounds of Singularity. Sources: repository docs/EVALUATION.md, docs/DEPLOYMENT.md, docs/PRODUCT_QA.md; official AI Builder Cup template preserved. Historical reference: https://science.nasa.gov/resource/apollo-8s-iconic-earthrise/. No claim of NASA endorsement. Working build and measurements verified October 17, 2026.</a:t>
+              <a:t>ProofMesh / Hounds of Singularity. Sources: repository docs/EVALUATION.md, docs/DEPLOYMENT.md, docs/PRODUCT_QA.md, docs/RAIL.md; official AI Builder Cup template preserved. Historical reference: https://science.nasa.gov/resource/apollo-8s-iconic-earthrise/. No claim of NASA endorsement. Working build and measurements verified October 17, 2026.</a:t>
             </a:r>
             <a:endParaRPr/>
           </a:p>
@@ -895,7 +895,7 @@
               <a:buNone/>
             </a:pPr>
             <a:r>
-              <a:t>ProofMesh / Hounds of Singularity. Sources: repository docs/EVALUATION.md, docs/DEPLOYMENT.md, docs/PRODUCT_QA.md; official AI Builder Cup template preserved. Historical reference: https://science.nasa.gov/resource/apollo-8s-iconic-earthrise/. No claim of NASA endorsement. Working build and measurements verified October 17, 2026.</a:t>
+              <a:t>ProofMesh / Hounds of Singularity. Sources: repository docs/EVALUATION.md, docs/DEPLOYMENT.md, docs/PRODUCT_QA.md, docs/RAIL.md; official AI Builder Cup template preserved. Historical reference: https://science.nasa.gov/resource/apollo-8s-iconic-earthrise/. No claim of NASA endorsement. Working build and measurements verified October 17, 2026.</a:t>
             </a:r>
             <a:endParaRPr/>
           </a:p>
@@ -975,7 +975,7 @@
               <a:buNone/>
             </a:pPr>
             <a:r>
-              <a:t>ProofMesh / Hounds of Singularity. Sources: repository docs/EVALUATION.md, docs/DEPLOYMENT.md, docs/PRODUCT_QA.md; official AI Builder Cup template preserved. Historical reference: https://science.nasa.gov/resource/apollo-8s-iconic-earthrise/. No claim of NASA endorsement. Working build and measurements verified October 17, 2026.</a:t>
+              <a:t>ProofMesh / Hounds of Singularity. Sources: repository docs/EVALUATION.md, docs/DEPLOYMENT.md, docs/PRODUCT_QA.md, docs/RAIL.md; official AI Builder Cup template preserved. Historical reference: https://science.nasa.gov/resource/apollo-8s-iconic-earthrise/. No claim of NASA endorsement. Working build and measurements verified October 17, 2026.</a:t>
             </a:r>
             <a:endParaRPr/>
           </a:p>
@@ -1055,7 +1055,7 @@
               <a:buNone/>
             </a:pPr>
             <a:r>
-              <a:t>ProofMesh / Hounds of Singularity. Sources: repository docs/EVALUATION.md, docs/DEPLOYMENT.md, docs/PRODUCT_QA.md; official AI Builder Cup template preserved. Historical reference: https://science.nasa.gov/resource/apollo-8s-iconic-earthrise/. No claim of NASA endorsement. Working build and measurements verified October 17, 2026.</a:t>
+              <a:t>ProofMesh / Hounds of Singularity. Sources: repository docs/EVALUATION.md, docs/DEPLOYMENT.md, docs/PRODUCT_QA.md, docs/RAIL.md; official AI Builder Cup template preserved. Historical reference: https://science.nasa.gov/resource/apollo-8s-iconic-earthrise/. No claim of NASA endorsement. Working build and measurements verified October 17, 2026.</a:t>
             </a:r>
             <a:endParaRPr/>
           </a:p>
@@ -1135,7 +1135,7 @@
               <a:buNone/>
             </a:pPr>
             <a:r>
-              <a:t>ProofMesh / Hounds of Singularity. Sources: repository docs/EVALUATION.md, docs/DEPLOYMENT.md, docs/PRODUCT_QA.md; official AI Builder Cup template preserved. Historical reference: https://science.nasa.gov/resource/apollo-8s-iconic-earthrise/. No claim of NASA endorsement. Working build and measurements verified October 17, 2026.</a:t>
+              <a:t>ProofMesh / Hounds of Singularity. Sources: repository docs/EVALUATION.md, docs/DEPLOYMENT.md, docs/PRODUCT_QA.md, docs/RAIL.md; official AI Builder Cup template preserved. Historical reference: https://science.nasa.gov/resource/apollo-8s-iconic-earthrise/. No claim of NASA endorsement. Working build and measurements verified October 17, 2026.</a:t>
             </a:r>
             <a:endParaRPr/>
           </a:p>
@@ -1215,7 +1215,7 @@
               <a:buNone/>
             </a:pPr>
             <a:r>
-              <a:t>ProofMesh / Hounds of Singularity. Sources: repository docs/EVALUATION.md, docs/DEPLOYMENT.md, docs/PRODUCT_QA.md; official AI Builder Cup template preserved. Historical reference: https://science.nasa.gov/resource/apollo-8s-iconic-earthrise/. No claim of NASA endorsement. Working build and measurements verified October 17, 2026.</a:t>
+              <a:t>ProofMesh / Hounds of Singularity. Sources: repository docs/EVALUATION.md, docs/DEPLOYMENT.md, docs/PRODUCT_QA.md, docs/RAIL.md; official AI Builder Cup template preserved. Historical reference: https://science.nasa.gov/resource/apollo-8s-iconic-earthrise/. No claim of NASA endorsement. Working build and measurements verified October 17, 2026.</a:t>
             </a:r>
             <a:endParaRPr/>
           </a:p>
@@ -1295,7 +1295,7 @@
               <a:buNone/>
             </a:pPr>
             <a:r>
-              <a:t>ProofMesh / Hounds of Singularity. Sources: repository docs/EVALUATION.md, docs/DEPLOYMENT.md, docs/PRODUCT_QA.md; official AI Builder Cup template preserved. Historical reference: https://science.nasa.gov/resource/apollo-8s-iconic-earthrise/. No claim of NASA endorsement. Working build and measurements verified October 17, 2026.</a:t>
+              <a:t>ProofMesh / Hounds of Singularity. Sources: repository docs/EVALUATION.md, docs/DEPLOYMENT.md, docs/PRODUCT_QA.md, docs/RAIL.md; official AI Builder Cup template preserved. Historical reference: https://science.nasa.gov/resource/apollo-8s-iconic-earthrise/. No claim of NASA endorsement. Working build and measurements verified October 17, 2026.</a:t>
             </a:r>
             <a:endParaRPr/>
           </a:p>
@@ -1375,7 +1375,7 @@
               <a:buNone/>
             </a:pPr>
             <a:r>
-              <a:t>ProofMesh / Hounds of Singularity. Sources: repository docs/EVALUATION.md, docs/DEPLOYMENT.md, docs/PRODUCT_QA.md; official AI Builder Cup template preserved. Historical reference: https://science.nasa.gov/resource/apollo-8s-iconic-earthrise/. No claim of NASA endorsement. Working build and measurements verified October 17, 2026.</a:t>
+              <a:t>ProofMesh / Hounds of Singularity. Sources: repository docs/EVALUATION.md, docs/DEPLOYMENT.md, docs/PRODUCT_QA.md, docs/RAIL.md; official AI Builder Cup template preserved. Historical reference: https://science.nasa.gov/resource/apollo-8s-iconic-earthrise/. No claim of NASA endorsement. Working build and measurements verified October 17, 2026.</a:t>
             </a:r>
             <a:endParaRPr/>
           </a:p>
@@ -1455,7 +1455,7 @@
               <a:buNone/>
             </a:pPr>
             <a:r>
-              <a:t>ProofMesh / Hounds of Singularity. Sources: repository docs/EVALUATION.md, docs/DEPLOYMENT.md, docs/PRODUCT_QA.md; official AI Builder Cup template preserved. Historical reference: https://science.nasa.gov/resource/apollo-8s-iconic-earthrise/. No claim of NASA endorsement. Working build and measurements verified October 17, 2026.</a:t>
+              <a:t>ProofMesh / Hounds of Singularity. Sources: repository docs/EVALUATION.md, docs/DEPLOYMENT.md, docs/PRODUCT_QA.md, docs/RAIL.md; official AI Builder Cup template preserved. Historical reference: https://science.nasa.gov/resource/apollo-8s-iconic-earthrise/. No claim of NASA endorsement. Working build and measurements verified October 17, 2026.</a:t>
             </a:r>
             <a:endParaRPr/>
           </a:p>
@@ -1535,7 +1535,7 @@
               <a:buNone/>
             </a:pPr>
             <a:r>
-              <a:t>ProofMesh / Hounds of Singularity. Sources: repository docs/EVALUATION.md, docs/DEPLOYMENT.md, docs/PRODUCT_QA.md; official AI Builder Cup template preserved. Historical reference: https://science.nasa.gov/resource/apollo-8s-iconic-earthrise/. No claim of NASA endorsement. Working build and measurements verified October 17, 2026.</a:t>
+              <a:t>ProofMesh / Hounds of Singularity. Sources: repository docs/EVALUATION.md, docs/DEPLOYMENT.md, docs/PRODUCT_QA.md, docs/RAIL.md; official AI Builder Cup template preserved. Historical reference: https://science.nasa.gov/resource/apollo-8s-iconic-earthrise/. No claim of NASA endorsement. Working build and measurements verified October 17, 2026.</a:t>
             </a:r>
             <a:endParaRPr/>
           </a:p>
@@ -1615,7 +1615,7 @@
               <a:buNone/>
             </a:pPr>
             <a:r>
-              <a:t>ProofMesh / Hounds of Singularity. Sources: repository docs/EVALUATION.md, docs/DEPLOYMENT.md, docs/PRODUCT_QA.md; official AI Builder Cup template preserved. Historical reference: https://science.nasa.gov/resource/apollo-8s-iconic-earthrise/. No claim of NASA endorsement. Working build and measurements verified October 17, 2026.</a:t>
+              <a:t>ProofMesh / Hounds of Singularity. Sources: repository docs/EVALUATION.md, docs/DEPLOYMENT.md, docs/PRODUCT_QA.md, docs/RAIL.md; official AI Builder Cup template preserved. Historical reference: https://science.nasa.gov/resource/apollo-8s-iconic-earthrise/. No claim of NASA endorsement. Working build and measurements verified October 17, 2026.</a:t>
             </a:r>
             <a:endParaRPr/>
           </a:p>
@@ -1695,7 +1695,7 @@
               <a:buNone/>
             </a:pPr>
             <a:r>
-              <a:t>ProofMesh / Hounds of Singularity. Sources: repository docs/EVALUATION.md, docs/DEPLOYMENT.md, docs/PRODUCT_QA.md; official AI Builder Cup template preserved. Historical reference: https://science.nasa.gov/resource/apollo-8s-iconic-earthrise/. No claim of NASA endorsement. Working build and measurements verified October 17, 2026.</a:t>
+              <a:t>ProofMesh / Hounds of Singularity. Sources: repository docs/EVALUATION.md, docs/DEPLOYMENT.md, docs/PRODUCT_QA.md, docs/RAIL.md; official AI Builder Cup template preserved. Historical reference: https://science.nasa.gov/resource/apollo-8s-iconic-earthrise/. No claim of NASA endorsement. Working build and measurements verified October 17, 2026.</a:t>
             </a:r>
             <a:endParaRPr/>
           </a:p>
@@ -1775,7 +1775,7 @@
               <a:buNone/>
             </a:pPr>
             <a:r>
-              <a:t>ProofMesh / Hounds of Singularity. Sources: repository docs/EVALUATION.md, docs/DEPLOYMENT.md, docs/PRODUCT_QA.md; official AI Builder Cup template preserved. Historical reference: https://science.nasa.gov/resource/apollo-8s-iconic-earthrise/. No claim of NASA endorsement. Working build and measurements verified October 17, 2026.</a:t>
+              <a:t>ProofMesh / Hounds of Singularity. Sources: repository docs/EVALUATION.md, docs/DEPLOYMENT.md, docs/PRODUCT_QA.md, docs/RAIL.md; official AI Builder Cup template preserved. Historical reference: https://science.nasa.gov/resource/apollo-8s-iconic-earthrise/. No claim of NASA endorsement. Working build and measurements verified October 17, 2026.</a:t>
             </a:r>
             <a:endParaRPr/>
           </a:p>
@@ -1855,7 +1855,7 @@
               <a:buNone/>
             </a:pPr>
             <a:r>
-              <a:t>ProofMesh / Hounds of Singularity. Sources: repository docs/EVALUATION.md, docs/DEPLOYMENT.md, docs/PRODUCT_QA.md; official AI Builder Cup template preserved. Historical reference: https://science.nasa.gov/resource/apollo-8s-iconic-earthrise/. No claim of NASA endorsement. Working build and measurements verified October 17, 2026.</a:t>
+              <a:t>ProofMesh / Hounds of Singularity. Sources: repository docs/EVALUATION.md, docs/DEPLOYMENT.md, docs/PRODUCT_QA.md, docs/RAIL.md; official AI Builder Cup template preserved. Historical reference: https://science.nasa.gov/resource/apollo-8s-iconic-earthrise/. No claim of NASA endorsement. Working build and measurements verified October 17, 2026.</a:t>
             </a:r>
             <a:endParaRPr/>
           </a:p>
@@ -1903,7 +1903,7 @@
           <p:cNvPr id="10" name="Google Shape;10;p2">
             <a:extLst xmlns:a="http://schemas.openxmlformats.org/drawingml/2006/main">
               <a:ext uri="{FF2B5EF4-FFF2-40B4-BE49-F238E27FC236}">
-                <a16:creationId xmlns:a16="http://schemas.microsoft.com/office/drawing/2014/main" id="{ECDDBEBB-C890-4A69-AED7-88182A9C0B1A}"/>
+                <a16:creationId xmlns:a16="http://schemas.microsoft.com/office/drawing/2014/main" id="{27D9F1AC-4C0F-4A26-9663-415A76593C89}"/>
               </a:ext>
             </a:extLst>
           </p:cNvPr>
@@ -2036,7 +2036,7 @@
           <p:cNvPr id="11" name="Google Shape;11;p2">
             <a:extLst xmlns:a="http://schemas.openxmlformats.org/drawingml/2006/main">
               <a:ext uri="{FF2B5EF4-FFF2-40B4-BE49-F238E27FC236}">
-                <a16:creationId xmlns:a16="http://schemas.microsoft.com/office/drawing/2014/main" id="{C7C972DC-E4B7-42B8-B5DC-97DB919DC525}"/>
+                <a16:creationId xmlns:a16="http://schemas.microsoft.com/office/drawing/2014/main" id="{46A2E7F2-B5F8-4AB5-B48A-D8BE9E1C2CF9}"/>
               </a:ext>
             </a:extLst>
           </p:cNvPr>
@@ -2196,7 +2196,7 @@
           <p:cNvPr id="12" name="Google Shape;12;p2">
             <a:extLst xmlns:a="http://schemas.openxmlformats.org/drawingml/2006/main">
               <a:ext uri="{FF2B5EF4-FFF2-40B4-BE49-F238E27FC236}">
-                <a16:creationId xmlns:a16="http://schemas.microsoft.com/office/drawing/2014/main" id="{54BBAF26-5F88-4ABE-8ED6-7710070813F0}"/>
+                <a16:creationId xmlns:a16="http://schemas.microsoft.com/office/drawing/2014/main" id="{33457C33-6CE8-46FA-AF1D-A6B2A5B2EF14}"/>
               </a:ext>
             </a:extLst>
           </p:cNvPr>
@@ -2297,7 +2297,7 @@
           <p:cNvPr id="45" name="Google Shape;45;p11">
             <a:extLst xmlns:a="http://schemas.openxmlformats.org/drawingml/2006/main">
               <a:ext uri="{FF2B5EF4-FFF2-40B4-BE49-F238E27FC236}">
-                <a16:creationId xmlns:a16="http://schemas.microsoft.com/office/drawing/2014/main" id="{900CE6F7-DFC2-4444-A8D1-C08E096D3E46}"/>
+                <a16:creationId xmlns:a16="http://schemas.microsoft.com/office/drawing/2014/main" id="{0C126177-9578-42AB-8B20-201BFCF794DF}"/>
               </a:ext>
             </a:extLst>
           </p:cNvPr>
@@ -2434,7 +2434,7 @@
           <p:cNvPr id="46" name="Google Shape;46;p11">
             <a:extLst xmlns:a="http://schemas.openxmlformats.org/drawingml/2006/main">
               <a:ext uri="{FF2B5EF4-FFF2-40B4-BE49-F238E27FC236}">
-                <a16:creationId xmlns:a16="http://schemas.microsoft.com/office/drawing/2014/main" id="{A45BF456-4CEC-40AD-81FA-47283608480B}"/>
+                <a16:creationId xmlns:a16="http://schemas.microsoft.com/office/drawing/2014/main" id="{CBF9E715-27E6-449B-BDA4-0EDBF5ADEC58}"/>
               </a:ext>
             </a:extLst>
           </p:cNvPr>
@@ -2567,7 +2567,7 @@
           <p:cNvPr id="47" name="Google Shape;47;p11">
             <a:extLst xmlns:a="http://schemas.openxmlformats.org/drawingml/2006/main">
               <a:ext uri="{FF2B5EF4-FFF2-40B4-BE49-F238E27FC236}">
-                <a16:creationId xmlns:a16="http://schemas.microsoft.com/office/drawing/2014/main" id="{BDD172DF-780B-4A23-B3C5-2054AEACEAAD}"/>
+                <a16:creationId xmlns:a16="http://schemas.microsoft.com/office/drawing/2014/main" id="{4455132F-0296-427C-BD3F-5EEA21417B83}"/>
               </a:ext>
             </a:extLst>
           </p:cNvPr>
@@ -2668,7 +2668,7 @@
           <p:cNvPr id="49" name="Google Shape;49;p12">
             <a:extLst xmlns:a="http://schemas.openxmlformats.org/drawingml/2006/main">
               <a:ext uri="{FF2B5EF4-FFF2-40B4-BE49-F238E27FC236}">
-                <a16:creationId xmlns:a16="http://schemas.microsoft.com/office/drawing/2014/main" id="{20FBC044-C52E-4BF2-BF01-D1C90A89C6DE}"/>
+                <a16:creationId xmlns:a16="http://schemas.microsoft.com/office/drawing/2014/main" id="{9E3C6D56-2A1D-4103-B384-3185C7705766}"/>
               </a:ext>
             </a:extLst>
           </p:cNvPr>
@@ -2769,7 +2769,7 @@
           <p:cNvPr id="14" name="Google Shape;14;p3">
             <a:extLst xmlns:a="http://schemas.openxmlformats.org/drawingml/2006/main">
               <a:ext uri="{FF2B5EF4-FFF2-40B4-BE49-F238E27FC236}">
-                <a16:creationId xmlns:a16="http://schemas.microsoft.com/office/drawing/2014/main" id="{E9AD9C1F-5934-483A-A5B9-75AA46A29B1E}"/>
+                <a16:creationId xmlns:a16="http://schemas.microsoft.com/office/drawing/2014/main" id="{510DED3D-FCA0-4A4F-9B50-DEAFC5BB5945}"/>
               </a:ext>
             </a:extLst>
           </p:cNvPr>
@@ -2902,7 +2902,7 @@
           <p:cNvPr id="15" name="Google Shape;15;p3">
             <a:extLst xmlns:a="http://schemas.openxmlformats.org/drawingml/2006/main">
               <a:ext uri="{FF2B5EF4-FFF2-40B4-BE49-F238E27FC236}">
-                <a16:creationId xmlns:a16="http://schemas.microsoft.com/office/drawing/2014/main" id="{3132AFC9-E6F7-4C56-A3B0-F013A0C6DDCA}"/>
+                <a16:creationId xmlns:a16="http://schemas.microsoft.com/office/drawing/2014/main" id="{065BC1F0-B8BA-46DB-A688-E9BCE05D9C1D}"/>
               </a:ext>
             </a:extLst>
           </p:cNvPr>
@@ -3003,7 +3003,7 @@
           <p:cNvPr id="17" name="Google Shape;17;p4">
             <a:extLst xmlns:a="http://schemas.openxmlformats.org/drawingml/2006/main">
               <a:ext uri="{FF2B5EF4-FFF2-40B4-BE49-F238E27FC236}">
-                <a16:creationId xmlns:a16="http://schemas.microsoft.com/office/drawing/2014/main" id="{84EA32C3-73BF-483C-9FA7-2898CAD071A6}"/>
+                <a16:creationId xmlns:a16="http://schemas.microsoft.com/office/drawing/2014/main" id="{8E54A3E0-7FA8-43C3-9B92-F4DC15923553}"/>
               </a:ext>
             </a:extLst>
           </p:cNvPr>
@@ -3136,7 +3136,7 @@
           <p:cNvPr id="18" name="Google Shape;18;p4">
             <a:extLst xmlns:a="http://schemas.openxmlformats.org/drawingml/2006/main">
               <a:ext uri="{FF2B5EF4-FFF2-40B4-BE49-F238E27FC236}">
-                <a16:creationId xmlns:a16="http://schemas.microsoft.com/office/drawing/2014/main" id="{A7CAD148-07C2-4C3E-96B6-9F3AF999764D}"/>
+                <a16:creationId xmlns:a16="http://schemas.microsoft.com/office/drawing/2014/main" id="{99618C41-7487-4653-883E-A13AC286A7B2}"/>
               </a:ext>
             </a:extLst>
           </p:cNvPr>
@@ -3269,7 +3269,7 @@
           <p:cNvPr id="19" name="Google Shape;19;p4">
             <a:extLst xmlns:a="http://schemas.openxmlformats.org/drawingml/2006/main">
               <a:ext uri="{FF2B5EF4-FFF2-40B4-BE49-F238E27FC236}">
-                <a16:creationId xmlns:a16="http://schemas.microsoft.com/office/drawing/2014/main" id="{1021333D-AA83-4EF2-83D0-00E1FD5D2F45}"/>
+                <a16:creationId xmlns:a16="http://schemas.microsoft.com/office/drawing/2014/main" id="{2A97EB7B-FF01-46CF-AD13-059E10B8627D}"/>
               </a:ext>
             </a:extLst>
           </p:cNvPr>
@@ -3370,7 +3370,7 @@
           <p:cNvPr id="21" name="Google Shape;21;p5">
             <a:extLst xmlns:a="http://schemas.openxmlformats.org/drawingml/2006/main">
               <a:ext uri="{FF2B5EF4-FFF2-40B4-BE49-F238E27FC236}">
-                <a16:creationId xmlns:a16="http://schemas.microsoft.com/office/drawing/2014/main" id="{2653AC79-34A1-48E2-BEF4-1B2D62F958F9}"/>
+                <a16:creationId xmlns:a16="http://schemas.microsoft.com/office/drawing/2014/main" id="{95C7FE75-5170-4076-9AA5-D0E68F31E943}"/>
               </a:ext>
             </a:extLst>
           </p:cNvPr>
@@ -3503,7 +3503,7 @@
           <p:cNvPr id="22" name="Google Shape;22;p5">
             <a:extLst xmlns:a="http://schemas.openxmlformats.org/drawingml/2006/main">
               <a:ext uri="{FF2B5EF4-FFF2-40B4-BE49-F238E27FC236}">
-                <a16:creationId xmlns:a16="http://schemas.microsoft.com/office/drawing/2014/main" id="{D1AC6F92-4C25-4547-A35A-6CDB68A1295B}"/>
+                <a16:creationId xmlns:a16="http://schemas.microsoft.com/office/drawing/2014/main" id="{9E28D4B1-E522-4750-A21E-8A224136F92A}"/>
               </a:ext>
             </a:extLst>
           </p:cNvPr>
@@ -3636,7 +3636,7 @@
           <p:cNvPr id="23" name="Google Shape;23;p5">
             <a:extLst xmlns:a="http://schemas.openxmlformats.org/drawingml/2006/main">
               <a:ext uri="{FF2B5EF4-FFF2-40B4-BE49-F238E27FC236}">
-                <a16:creationId xmlns:a16="http://schemas.microsoft.com/office/drawing/2014/main" id="{A4F59FA4-08D4-44C3-9F40-A8703C2E1B9C}"/>
+                <a16:creationId xmlns:a16="http://schemas.microsoft.com/office/drawing/2014/main" id="{5AB1B9D7-B6F7-4AA2-AEA1-5647F20AB0D6}"/>
               </a:ext>
             </a:extLst>
           </p:cNvPr>
@@ -3769,7 +3769,7 @@
           <p:cNvPr id="24" name="Google Shape;24;p5">
             <a:extLst xmlns:a="http://schemas.openxmlformats.org/drawingml/2006/main">
               <a:ext uri="{FF2B5EF4-FFF2-40B4-BE49-F238E27FC236}">
-                <a16:creationId xmlns:a16="http://schemas.microsoft.com/office/drawing/2014/main" id="{249A22A6-00E1-4E9A-B151-6A1EFC98F927}"/>
+                <a16:creationId xmlns:a16="http://schemas.microsoft.com/office/drawing/2014/main" id="{73C3BFC4-3C0A-4E24-B852-47A502F980C4}"/>
               </a:ext>
             </a:extLst>
           </p:cNvPr>
@@ -3870,7 +3870,7 @@
           <p:cNvPr id="26" name="Google Shape;26;p6">
             <a:extLst xmlns:a="http://schemas.openxmlformats.org/drawingml/2006/main">
               <a:ext uri="{FF2B5EF4-FFF2-40B4-BE49-F238E27FC236}">
-                <a16:creationId xmlns:a16="http://schemas.microsoft.com/office/drawing/2014/main" id="{C563A752-69DF-4BD5-82D9-0871A3F16082}"/>
+                <a16:creationId xmlns:a16="http://schemas.microsoft.com/office/drawing/2014/main" id="{248F807D-EAAC-4171-A8B3-166E9A7FE0B6}"/>
               </a:ext>
             </a:extLst>
           </p:cNvPr>
@@ -4003,7 +4003,7 @@
           <p:cNvPr id="27" name="Google Shape;27;p6">
             <a:extLst xmlns:a="http://schemas.openxmlformats.org/drawingml/2006/main">
               <a:ext uri="{FF2B5EF4-FFF2-40B4-BE49-F238E27FC236}">
-                <a16:creationId xmlns:a16="http://schemas.microsoft.com/office/drawing/2014/main" id="{D9593977-998A-40E5-B892-700867476E95}"/>
+                <a16:creationId xmlns:a16="http://schemas.microsoft.com/office/drawing/2014/main" id="{5CEB62DE-F863-42A6-A29A-538BCAEECC0A}"/>
               </a:ext>
             </a:extLst>
           </p:cNvPr>
@@ -4104,7 +4104,7 @@
           <p:cNvPr id="29" name="Google Shape;29;p7">
             <a:extLst xmlns:a="http://schemas.openxmlformats.org/drawingml/2006/main">
               <a:ext uri="{FF2B5EF4-FFF2-40B4-BE49-F238E27FC236}">
-                <a16:creationId xmlns:a16="http://schemas.microsoft.com/office/drawing/2014/main" id="{342304BA-FED9-4C4F-8834-72DFC1DF5D42}"/>
+                <a16:creationId xmlns:a16="http://schemas.microsoft.com/office/drawing/2014/main" id="{9FA4BC9B-8FEB-47DE-B7DA-FC2A24B758E0}"/>
               </a:ext>
             </a:extLst>
           </p:cNvPr>
@@ -4237,7 +4237,7 @@
           <p:cNvPr id="30" name="Google Shape;30;p7">
             <a:extLst xmlns:a="http://schemas.openxmlformats.org/drawingml/2006/main">
               <a:ext uri="{FF2B5EF4-FFF2-40B4-BE49-F238E27FC236}">
-                <a16:creationId xmlns:a16="http://schemas.microsoft.com/office/drawing/2014/main" id="{36D33249-693F-444D-9E54-45126524EC65}"/>
+                <a16:creationId xmlns:a16="http://schemas.microsoft.com/office/drawing/2014/main" id="{C2EF4A15-5623-4D01-9AEE-7C0515C90A57}"/>
               </a:ext>
             </a:extLst>
           </p:cNvPr>
@@ -4370,7 +4370,7 @@
           <p:cNvPr id="31" name="Google Shape;31;p7">
             <a:extLst xmlns:a="http://schemas.openxmlformats.org/drawingml/2006/main">
               <a:ext uri="{FF2B5EF4-FFF2-40B4-BE49-F238E27FC236}">
-                <a16:creationId xmlns:a16="http://schemas.microsoft.com/office/drawing/2014/main" id="{69F4B710-1EC4-4452-8C74-5C305EDF701D}"/>
+                <a16:creationId xmlns:a16="http://schemas.microsoft.com/office/drawing/2014/main" id="{23F17D81-3D72-4F6D-ADBD-397B1E690B07}"/>
               </a:ext>
             </a:extLst>
           </p:cNvPr>
@@ -4471,7 +4471,7 @@
           <p:cNvPr id="33" name="Google Shape;33;p8">
             <a:extLst xmlns:a="http://schemas.openxmlformats.org/drawingml/2006/main">
               <a:ext uri="{FF2B5EF4-FFF2-40B4-BE49-F238E27FC236}">
-                <a16:creationId xmlns:a16="http://schemas.microsoft.com/office/drawing/2014/main" id="{EC027238-7B73-4C39-B14C-17741520945F}"/>
+                <a16:creationId xmlns:a16="http://schemas.microsoft.com/office/drawing/2014/main" id="{13E8AE35-AC56-4EE2-960B-D156BE52B16E}"/>
               </a:ext>
             </a:extLst>
           </p:cNvPr>
@@ -4604,7 +4604,7 @@
           <p:cNvPr id="34" name="Google Shape;34;p8">
             <a:extLst xmlns:a="http://schemas.openxmlformats.org/drawingml/2006/main">
               <a:ext uri="{FF2B5EF4-FFF2-40B4-BE49-F238E27FC236}">
-                <a16:creationId xmlns:a16="http://schemas.microsoft.com/office/drawing/2014/main" id="{A92B73CB-B817-464B-936B-88E309EA15DC}"/>
+                <a16:creationId xmlns:a16="http://schemas.microsoft.com/office/drawing/2014/main" id="{C60D2BE4-8724-451E-B27A-5371EEB8741A}"/>
               </a:ext>
             </a:extLst>
           </p:cNvPr>
@@ -4705,7 +4705,7 @@
           <p:cNvPr id="36" name="Google Shape;36;p9">
             <a:extLst xmlns:a="http://schemas.openxmlformats.org/drawingml/2006/main">
               <a:ext uri="{FF2B5EF4-FFF2-40B4-BE49-F238E27FC236}">
-                <a16:creationId xmlns:a16="http://schemas.microsoft.com/office/drawing/2014/main" id="{374D530E-46F6-4827-A4B2-22C8E980AE0D}"/>
+                <a16:creationId xmlns:a16="http://schemas.microsoft.com/office/drawing/2014/main" id="{132B2DB1-EA3F-46AD-BBC5-8512A9DAD869}"/>
               </a:ext>
             </a:extLst>
           </p:cNvPr>
@@ -4756,7 +4756,7 @@
           <p:cNvPr id="37" name="Google Shape;37;p9">
             <a:extLst xmlns:a="http://schemas.openxmlformats.org/drawingml/2006/main">
               <a:ext uri="{FF2B5EF4-FFF2-40B4-BE49-F238E27FC236}">
-                <a16:creationId xmlns:a16="http://schemas.microsoft.com/office/drawing/2014/main" id="{DD7E8773-089D-488C-872D-AD2A9C848CFB}"/>
+                <a16:creationId xmlns:a16="http://schemas.microsoft.com/office/drawing/2014/main" id="{A914526D-EA0E-41BC-8431-655E0EFC2DB8}"/>
               </a:ext>
             </a:extLst>
           </p:cNvPr>
@@ -4889,7 +4889,7 @@
           <p:cNvPr id="38" name="Google Shape;38;p9">
             <a:extLst xmlns:a="http://schemas.openxmlformats.org/drawingml/2006/main">
               <a:ext uri="{FF2B5EF4-FFF2-40B4-BE49-F238E27FC236}">
-                <a16:creationId xmlns:a16="http://schemas.microsoft.com/office/drawing/2014/main" id="{594D9F8F-0181-4B50-9065-860159774B39}"/>
+                <a16:creationId xmlns:a16="http://schemas.microsoft.com/office/drawing/2014/main" id="{FF8A1352-6D8D-4D85-A652-7B03ABDF5192}"/>
               </a:ext>
             </a:extLst>
           </p:cNvPr>
@@ -5049,7 +5049,7 @@
           <p:cNvPr id="39" name="Google Shape;39;p9">
             <a:extLst xmlns:a="http://schemas.openxmlformats.org/drawingml/2006/main">
               <a:ext uri="{FF2B5EF4-FFF2-40B4-BE49-F238E27FC236}">
-                <a16:creationId xmlns:a16="http://schemas.microsoft.com/office/drawing/2014/main" id="{54047A95-C09D-45D5-8726-622D1837E39C}"/>
+                <a16:creationId xmlns:a16="http://schemas.microsoft.com/office/drawing/2014/main" id="{BA7EFE5B-80F9-4EDD-AA82-D41228C120AF}"/>
               </a:ext>
             </a:extLst>
           </p:cNvPr>
@@ -5182,7 +5182,7 @@
           <p:cNvPr id="40" name="Google Shape;40;p9">
             <a:extLst xmlns:a="http://schemas.openxmlformats.org/drawingml/2006/main">
               <a:ext uri="{FF2B5EF4-FFF2-40B4-BE49-F238E27FC236}">
-                <a16:creationId xmlns:a16="http://schemas.microsoft.com/office/drawing/2014/main" id="{3DB8C613-C51B-415B-822C-84BCD404ED66}"/>
+                <a16:creationId xmlns:a16="http://schemas.microsoft.com/office/drawing/2014/main" id="{1AFEC17F-8F59-4B57-B64A-956307BA1A80}"/>
               </a:ext>
             </a:extLst>
           </p:cNvPr>
@@ -5283,7 +5283,7 @@
           <p:cNvPr id="42" name="Google Shape;42;p10">
             <a:extLst xmlns:a="http://schemas.openxmlformats.org/drawingml/2006/main">
               <a:ext uri="{FF2B5EF4-FFF2-40B4-BE49-F238E27FC236}">
-                <a16:creationId xmlns:a16="http://schemas.microsoft.com/office/drawing/2014/main" id="{6D3FDCCE-7F0E-40BB-A00E-4CE317877E74}"/>
+                <a16:creationId xmlns:a16="http://schemas.microsoft.com/office/drawing/2014/main" id="{321B2A48-62D8-4C05-9F4A-0030AEC95A04}"/>
               </a:ext>
             </a:extLst>
           </p:cNvPr>
@@ -5331,7 +5331,7 @@
           <p:cNvPr id="43" name="Google Shape;43;p10">
             <a:extLst xmlns:a="http://schemas.openxmlformats.org/drawingml/2006/main">
               <a:ext uri="{FF2B5EF4-FFF2-40B4-BE49-F238E27FC236}">
-                <a16:creationId xmlns:a16="http://schemas.microsoft.com/office/drawing/2014/main" id="{FC48B84F-4012-4B4E-B157-B0023CD8142D}"/>
+                <a16:creationId xmlns:a16="http://schemas.microsoft.com/office/drawing/2014/main" id="{FCC615BE-E89F-48E2-B9CD-205DC7C984C5}"/>
               </a:ext>
             </a:extLst>
           </p:cNvPr>
@@ -5439,7 +5439,7 @@
           <p:cNvPr id="6" name="Google Shape;6;p1">
             <a:extLst xmlns:a="http://schemas.openxmlformats.org/drawingml/2006/main">
               <a:ext uri="{FF2B5EF4-FFF2-40B4-BE49-F238E27FC236}">
-                <a16:creationId xmlns:a16="http://schemas.microsoft.com/office/drawing/2014/main" id="{989C8ADE-EC4E-4F2A-BCFD-C53EB5EBB7E9}"/>
+                <a16:creationId xmlns:a16="http://schemas.microsoft.com/office/drawing/2014/main" id="{EB1CDB1C-623A-493F-8218-07A9AFF3CB1B}"/>
               </a:ext>
             </a:extLst>
           </p:cNvPr>
@@ -5639,7 +5639,7 @@
           <p:cNvPr id="7" name="Google Shape;7;p1">
             <a:extLst xmlns:a="http://schemas.openxmlformats.org/drawingml/2006/main">
               <a:ext uri="{FF2B5EF4-FFF2-40B4-BE49-F238E27FC236}">
-                <a16:creationId xmlns:a16="http://schemas.microsoft.com/office/drawing/2014/main" id="{AD701BCE-C341-4532-9327-03F1F0AA1CD0}"/>
+                <a16:creationId xmlns:a16="http://schemas.microsoft.com/office/drawing/2014/main" id="{995A435C-5C01-43FE-A5F0-4A2E9EB8C64A}"/>
               </a:ext>
             </a:extLst>
           </p:cNvPr>
@@ -5866,7 +5866,7 @@
           <p:cNvPr id="8" name="Google Shape;8;p1">
             <a:extLst xmlns:a="http://schemas.openxmlformats.org/drawingml/2006/main">
               <a:ext uri="{FF2B5EF4-FFF2-40B4-BE49-F238E27FC236}">
-                <a16:creationId xmlns:a16="http://schemas.microsoft.com/office/drawing/2014/main" id="{51DF79B7-54F7-4AD8-B661-E5661D95D62C}"/>
+                <a16:creationId xmlns:a16="http://schemas.microsoft.com/office/drawing/2014/main" id="{2E25322F-3516-4898-92CD-3D75054070C6}"/>
               </a:ext>
             </a:extLst>
           </p:cNvPr>
@@ -5989,17 +5989,17 @@
   </p:cSld>
   <p:clrMap bg1="lt1" tx1="dk1" bg2="dk2" tx2="lt2" accent1="accent1" accent2="accent2" accent3="accent3" accent4="accent4" accent5="accent5" accent6="accent6" hlink="hlink" folHlink="folHlink"/>
   <p:sldLayoutIdLst>
-    <p:sldLayoutId xmlns:r="http://schemas.openxmlformats.org/officeDocument/2006/relationships" id="2147483649" r:id="Rd13042f3a29e4be7"/>
-    <p:sldLayoutId xmlns:r="http://schemas.openxmlformats.org/officeDocument/2006/relationships" id="2147483650" r:id="R29d0235f268744a8"/>
-    <p:sldLayoutId xmlns:r="http://schemas.openxmlformats.org/officeDocument/2006/relationships" id="2147483651" r:id="Rc62d7cce9bfa4137"/>
-    <p:sldLayoutId xmlns:r="http://schemas.openxmlformats.org/officeDocument/2006/relationships" id="2147483652" r:id="Ra62a45262be94693"/>
-    <p:sldLayoutId xmlns:r="http://schemas.openxmlformats.org/officeDocument/2006/relationships" id="2147483653" r:id="Rb5dc7a2ad5fa4933"/>
-    <p:sldLayoutId xmlns:r="http://schemas.openxmlformats.org/officeDocument/2006/relationships" id="2147483654" r:id="R597243311e224b38"/>
-    <p:sldLayoutId xmlns:r="http://schemas.openxmlformats.org/officeDocument/2006/relationships" id="2147483655" r:id="Rab9710e7943f407e"/>
-    <p:sldLayoutId xmlns:r="http://schemas.openxmlformats.org/officeDocument/2006/relationships" id="2147483656" r:id="Rec0d4ffc663b497b"/>
-    <p:sldLayoutId xmlns:r="http://schemas.openxmlformats.org/officeDocument/2006/relationships" id="2147483657" r:id="R4c456abb76ef4eb6"/>
-    <p:sldLayoutId xmlns:r="http://schemas.openxmlformats.org/officeDocument/2006/relationships" id="2147483658" r:id="R699085d9a1d0435b"/>
-    <p:sldLayoutId xmlns:r="http://schemas.openxmlformats.org/officeDocument/2006/relationships" id="2147483659" r:id="Rb45a62cabecb4edb"/>
+    <p:sldLayoutId xmlns:r="http://schemas.openxmlformats.org/officeDocument/2006/relationships" id="2147483649" r:id="R4cddfb50efaa4f3e"/>
+    <p:sldLayoutId xmlns:r="http://schemas.openxmlformats.org/officeDocument/2006/relationships" id="2147483650" r:id="R83eba44fe1524829"/>
+    <p:sldLayoutId xmlns:r="http://schemas.openxmlformats.org/officeDocument/2006/relationships" id="2147483651" r:id="R5e82857883774154"/>
+    <p:sldLayoutId xmlns:r="http://schemas.openxmlformats.org/officeDocument/2006/relationships" id="2147483652" r:id="R40d80f548ab34c9a"/>
+    <p:sldLayoutId xmlns:r="http://schemas.openxmlformats.org/officeDocument/2006/relationships" id="2147483653" r:id="R1d34213d8c334560"/>
+    <p:sldLayoutId xmlns:r="http://schemas.openxmlformats.org/officeDocument/2006/relationships" id="2147483654" r:id="R4aa2ad60ea2f4b72"/>
+    <p:sldLayoutId xmlns:r="http://schemas.openxmlformats.org/officeDocument/2006/relationships" id="2147483655" r:id="R49205c87789e4980"/>
+    <p:sldLayoutId xmlns:r="http://schemas.openxmlformats.org/officeDocument/2006/relationships" id="2147483656" r:id="R6c4467d89d5044d5"/>
+    <p:sldLayoutId xmlns:r="http://schemas.openxmlformats.org/officeDocument/2006/relationships" id="2147483657" r:id="R4d59a4f6d1254ce7"/>
+    <p:sldLayoutId xmlns:r="http://schemas.openxmlformats.org/officeDocument/2006/relationships" id="2147483658" r:id="R4fb73fa1ebea463c"/>
+    <p:sldLayoutId xmlns:r="http://schemas.openxmlformats.org/officeDocument/2006/relationships" id="2147483659" r:id="Ra065013416694b77"/>
   </p:sldLayoutIdLst>
   <p:hf sldNum="0" hdr="0" ftr="0" dt="0"/>
   <p:txStyles>
@@ -6946,7 +6946,7 @@
           <p:cNvPr id="54" name="Google Shape;54;p13">
             <a:extLst xmlns:a="http://schemas.openxmlformats.org/drawingml/2006/main">
               <a:ext uri="{FF2B5EF4-FFF2-40B4-BE49-F238E27FC236}">
-                <a16:creationId xmlns:a16="http://schemas.microsoft.com/office/drawing/2014/main" id="{1AA63442-0D4A-4BF5-B4F4-65329470DB31}"/>
+                <a16:creationId xmlns:a16="http://schemas.microsoft.com/office/drawing/2014/main" id="{EF464361-E72C-4494-B0EC-C8EAD0EA7DA1}"/>
               </a:ext>
             </a:extLst>
           </p:cNvPr>
@@ -7026,7 +7026,7 @@
           <p:cNvPr id="55" name="Google Shape;55;p13">
             <a:extLst xmlns:a="http://schemas.openxmlformats.org/drawingml/2006/main">
               <a:ext uri="{FF2B5EF4-FFF2-40B4-BE49-F238E27FC236}">
-                <a16:creationId xmlns:a16="http://schemas.microsoft.com/office/drawing/2014/main" id="{F7970F92-2FC9-402D-8FB8-4ED493B086B6}"/>
+                <a16:creationId xmlns:a16="http://schemas.microsoft.com/office/drawing/2014/main" id="{4C4D2FC7-CA16-42F8-A998-5BF082557532}"/>
               </a:ext>
             </a:extLst>
           </p:cNvPr>
@@ -7036,7 +7036,7 @@
           <p:nvPr/>
         </p:nvPicPr>
         <p:blipFill>
-          <a:blip xmlns:r="http://schemas.openxmlformats.org/officeDocument/2006/relationships" xmlns:a="http://schemas.openxmlformats.org/drawingml/2006/main" r:embed="R60e0b8461e124774">
+          <a:blip xmlns:r="http://schemas.openxmlformats.org/officeDocument/2006/relationships" xmlns:a="http://schemas.openxmlformats.org/drawingml/2006/main" r:embed="Rc379ed33f31f4eb8">
             <a:alphaModFix/>
           </a:blip>
           <a:stretch xmlns:a="http://schemas.openxmlformats.org/drawingml/2006/main">
@@ -7061,7 +7061,7 @@
           <p:cNvPr id="56" name="Google Shape;56;p13">
             <a:extLst xmlns:a="http://schemas.openxmlformats.org/drawingml/2006/main">
               <a:ext uri="{FF2B5EF4-FFF2-40B4-BE49-F238E27FC236}">
-                <a16:creationId xmlns:a16="http://schemas.microsoft.com/office/drawing/2014/main" id="{7446F0B0-B275-4FB0-8F78-91071A05AA6C}"/>
+                <a16:creationId xmlns:a16="http://schemas.microsoft.com/office/drawing/2014/main" id="{DC376C5F-EBCE-4107-BB7A-1DC6CD6D642C}"/>
               </a:ext>
             </a:extLst>
           </p:cNvPr>
@@ -7071,7 +7071,7 @@
           <p:nvPr/>
         </p:nvPicPr>
         <p:blipFill rotWithShape="1">
-          <a:blip xmlns:r="http://schemas.openxmlformats.org/officeDocument/2006/relationships" xmlns:a="http://schemas.openxmlformats.org/drawingml/2006/main" r:embed="Rb5a8c5f608cc43b4">
+          <a:blip xmlns:r="http://schemas.openxmlformats.org/officeDocument/2006/relationships" xmlns:a="http://schemas.openxmlformats.org/drawingml/2006/main" r:embed="R97cf6519ee3442a1">
             <a:alphaModFix/>
           </a:blip>
           <a:srcRect xmlns:a="http://schemas.openxmlformats.org/drawingml/2006/main" l="0" t="0" r="0" b="98001"/>
@@ -7095,7 +7095,7 @@
           <p:cNvPr id="57" name="">
             <a:extLst xmlns:a="http://schemas.openxmlformats.org/drawingml/2006/main">
               <a:ext uri="{FF2B5EF4-FFF2-40B4-BE49-F238E27FC236}">
-                <a16:creationId xmlns:a16="http://schemas.microsoft.com/office/drawing/2014/main" id="{D041B516-A296-4FF1-840A-758232075709}"/>
+                <a16:creationId xmlns:a16="http://schemas.microsoft.com/office/drawing/2014/main" id="{5CE8C144-FA2F-46CC-A36F-75AA683D89DF}"/>
               </a:ext>
             </a:extLst>
           </p:cNvPr>
@@ -7207,7 +7207,7 @@
           <p:cNvPr id="58" name="">
             <a:extLst xmlns:a="http://schemas.openxmlformats.org/drawingml/2006/main">
               <a:ext uri="{FF2B5EF4-FFF2-40B4-BE49-F238E27FC236}">
-                <a16:creationId xmlns:a16="http://schemas.microsoft.com/office/drawing/2014/main" id="{EC706CC1-1138-46D3-9DDE-15D169FF4943}"/>
+                <a16:creationId xmlns:a16="http://schemas.microsoft.com/office/drawing/2014/main" id="{3AFEB6B3-3A39-44E5-B07F-CF65110C12D7}"/>
               </a:ext>
             </a:extLst>
           </p:cNvPr>
@@ -7271,7 +7271,7 @@
     </p:spTree>
     <p:extLst>
       <p:ext uri="{BB962C8B-B14F-4D97-AF65-F5344CB8AC3E}">
-        <p14:creationId xmlns:p14="http://schemas.microsoft.com/office/powerpoint/2010/main" val="1989965566"/>
+        <p14:creationId xmlns:p14="http://schemas.microsoft.com/office/powerpoint/2010/main" val="638114017"/>
       </p:ext>
     </p:extLst>
   </p:cSld>
@@ -7295,7 +7295,7 @@
           <p:cNvPr id="132" name="Google Shape;132;p23">
             <a:extLst xmlns:a="http://schemas.openxmlformats.org/drawingml/2006/main">
               <a:ext uri="{FF2B5EF4-FFF2-40B4-BE49-F238E27FC236}">
-                <a16:creationId xmlns:a16="http://schemas.microsoft.com/office/drawing/2014/main" id="{96010F3B-0DAC-4B99-A80F-D2E55935EE6E}"/>
+                <a16:creationId xmlns:a16="http://schemas.microsoft.com/office/drawing/2014/main" id="{FBC2C982-1054-4985-B83C-8A95D25E3469}"/>
               </a:ext>
             </a:extLst>
           </p:cNvPr>
@@ -7305,7 +7305,7 @@
           <p:nvPr/>
         </p:nvPicPr>
         <p:blipFill rotWithShape="1">
-          <a:blip xmlns:r="http://schemas.openxmlformats.org/officeDocument/2006/relationships" xmlns:a="http://schemas.openxmlformats.org/drawingml/2006/main" r:embed="R2e19f9876a7a487c">
+          <a:blip xmlns:r="http://schemas.openxmlformats.org/officeDocument/2006/relationships" xmlns:a="http://schemas.openxmlformats.org/drawingml/2006/main" r:embed="R7bd4977342594dbf">
             <a:alphaModFix/>
           </a:blip>
           <a:srcRect xmlns:a="http://schemas.openxmlformats.org/drawingml/2006/main" l="0" t="0" r="0" b="98001"/>
@@ -7329,7 +7329,7 @@
           <p:cNvPr id="133" name="Google Shape;133;p23">
             <a:extLst xmlns:a="http://schemas.openxmlformats.org/drawingml/2006/main">
               <a:ext uri="{FF2B5EF4-FFF2-40B4-BE49-F238E27FC236}">
-                <a16:creationId xmlns:a16="http://schemas.microsoft.com/office/drawing/2014/main" id="{E2D12AC6-D2F3-4782-A352-2F2C209042B2}"/>
+                <a16:creationId xmlns:a16="http://schemas.microsoft.com/office/drawing/2014/main" id="{739B54A1-2B3F-45CF-8527-D223CFC1A1BA}"/>
               </a:ext>
             </a:extLst>
           </p:cNvPr>
@@ -7339,7 +7339,7 @@
           <p:nvPr/>
         </p:nvPicPr>
         <p:blipFill>
-          <a:blip xmlns:r="http://schemas.openxmlformats.org/officeDocument/2006/relationships" xmlns:a="http://schemas.openxmlformats.org/drawingml/2006/main" r:embed="Rb4615bba6aba4c29">
+          <a:blip xmlns:r="http://schemas.openxmlformats.org/officeDocument/2006/relationships" xmlns:a="http://schemas.openxmlformats.org/drawingml/2006/main" r:embed="Rf4f1f90b2f5b4a67">
             <a:alphaModFix/>
           </a:blip>
           <a:stretch xmlns:a="http://schemas.openxmlformats.org/drawingml/2006/main">
@@ -7364,7 +7364,7 @@
           <p:cNvPr id="134" name="Google Shape;134;p23">
             <a:extLst xmlns:a="http://schemas.openxmlformats.org/drawingml/2006/main">
               <a:ext uri="{FF2B5EF4-FFF2-40B4-BE49-F238E27FC236}">
-                <a16:creationId xmlns:a16="http://schemas.microsoft.com/office/drawing/2014/main" id="{7E7C8255-5E8A-41DF-8731-6918EA8FA4FD}"/>
+                <a16:creationId xmlns:a16="http://schemas.microsoft.com/office/drawing/2014/main" id="{7BD38434-D347-47EE-80D5-0F3EFA86D7A3}"/>
               </a:ext>
             </a:extLst>
           </p:cNvPr>
@@ -7415,7 +7415,7 @@
           <p:cNvPr id="135" name="Google Shape;135;p23">
             <a:extLst xmlns:a="http://schemas.openxmlformats.org/drawingml/2006/main">
               <a:ext uri="{FF2B5EF4-FFF2-40B4-BE49-F238E27FC236}">
-                <a16:creationId xmlns:a16="http://schemas.microsoft.com/office/drawing/2014/main" id="{9A440705-43EC-4502-9525-4420D58B9846}"/>
+                <a16:creationId xmlns:a16="http://schemas.microsoft.com/office/drawing/2014/main" id="{269B34D7-B591-48FB-B5D4-948AD9199E8D}"/>
               </a:ext>
             </a:extLst>
           </p:cNvPr>
@@ -7473,7 +7473,7 @@
           <p:cNvPr id="136" name="">
             <a:extLst xmlns:a="http://schemas.openxmlformats.org/drawingml/2006/main">
               <a:ext uri="{FF2B5EF4-FFF2-40B4-BE49-F238E27FC236}">
-                <a16:creationId xmlns:a16="http://schemas.microsoft.com/office/drawing/2014/main" id="{1758E40B-D921-41D6-9D49-B189082FEBC8}"/>
+                <a16:creationId xmlns:a16="http://schemas.microsoft.com/office/drawing/2014/main" id="{117CFA6B-3398-40CB-B215-CEB6A43D4EDC}"/>
               </a:ext>
             </a:extLst>
           </p:cNvPr>
@@ -7483,7 +7483,7 @@
           <p:nvPr/>
         </p:nvPicPr>
         <p:blipFill>
-          <a:blip xmlns:r="http://schemas.openxmlformats.org/officeDocument/2006/relationships" xmlns:a="http://schemas.openxmlformats.org/drawingml/2006/main" r:embed="R4d44ab09b6ec48c0"/>
+          <a:blip xmlns:r="http://schemas.openxmlformats.org/officeDocument/2006/relationships" xmlns:a="http://schemas.openxmlformats.org/drawingml/2006/main" r:embed="Re4231efef1e04786"/>
           <a:stretch xmlns:a="http://schemas.openxmlformats.org/drawingml/2006/main"/>
         </p:blipFill>
         <p:spPr>
@@ -7501,7 +7501,7 @@
           <p:cNvPr id="137" name="">
             <a:extLst xmlns:a="http://schemas.openxmlformats.org/drawingml/2006/main">
               <a:ext uri="{FF2B5EF4-FFF2-40B4-BE49-F238E27FC236}">
-                <a16:creationId xmlns:a16="http://schemas.microsoft.com/office/drawing/2014/main" id="{598A082C-F677-4812-8F82-EACAE8624A11}"/>
+                <a16:creationId xmlns:a16="http://schemas.microsoft.com/office/drawing/2014/main" id="{48BA4AB8-A9B0-4DF3-8E2A-F243C6A9C652}"/>
               </a:ext>
             </a:extLst>
           </p:cNvPr>
@@ -7511,7 +7511,7 @@
           <p:nvPr/>
         </p:nvPicPr>
         <p:blipFill>
-          <a:blip xmlns:r="http://schemas.openxmlformats.org/officeDocument/2006/relationships" xmlns:a="http://schemas.openxmlformats.org/drawingml/2006/main" r:embed="R60ae7ef722414c4d"/>
+          <a:blip xmlns:r="http://schemas.openxmlformats.org/officeDocument/2006/relationships" xmlns:a="http://schemas.openxmlformats.org/drawingml/2006/main" r:embed="Rfc4408a176114d1d"/>
           <a:stretch xmlns:a="http://schemas.openxmlformats.org/drawingml/2006/main"/>
         </p:blipFill>
         <p:spPr>
@@ -7527,7 +7527,7 @@
     </p:spTree>
     <p:extLst>
       <p:ext uri="{BB962C8B-B14F-4D97-AF65-F5344CB8AC3E}">
-        <p14:creationId xmlns:p14="http://schemas.microsoft.com/office/powerpoint/2010/main" val="599635811"/>
+        <p14:creationId xmlns:p14="http://schemas.microsoft.com/office/powerpoint/2010/main" val="324254597"/>
       </p:ext>
     </p:extLst>
   </p:cSld>
@@ -7551,7 +7551,7 @@
           <p:cNvPr id="140" name="Google Shape;140;p24">
             <a:extLst xmlns:a="http://schemas.openxmlformats.org/drawingml/2006/main">
               <a:ext uri="{FF2B5EF4-FFF2-40B4-BE49-F238E27FC236}">
-                <a16:creationId xmlns:a16="http://schemas.microsoft.com/office/drawing/2014/main" id="{CB7DEC22-DF6A-4542-A80D-965FFB39E26F}"/>
+                <a16:creationId xmlns:a16="http://schemas.microsoft.com/office/drawing/2014/main" id="{87782506-10B5-4E37-B663-7BBCE770B94D}"/>
               </a:ext>
             </a:extLst>
           </p:cNvPr>
@@ -7561,7 +7561,7 @@
           <p:nvPr/>
         </p:nvPicPr>
         <p:blipFill rotWithShape="1">
-          <a:blip xmlns:r="http://schemas.openxmlformats.org/officeDocument/2006/relationships" xmlns:a="http://schemas.openxmlformats.org/drawingml/2006/main" r:embed="R09370a3eb69b486f">
+          <a:blip xmlns:r="http://schemas.openxmlformats.org/officeDocument/2006/relationships" xmlns:a="http://schemas.openxmlformats.org/drawingml/2006/main" r:embed="R74353f83e80d4e60">
             <a:alphaModFix/>
           </a:blip>
           <a:srcRect xmlns:a="http://schemas.openxmlformats.org/drawingml/2006/main" l="0" t="0" r="0" b="98001"/>
@@ -7585,7 +7585,7 @@
           <p:cNvPr id="141" name="Google Shape;141;p24">
             <a:extLst xmlns:a="http://schemas.openxmlformats.org/drawingml/2006/main">
               <a:ext uri="{FF2B5EF4-FFF2-40B4-BE49-F238E27FC236}">
-                <a16:creationId xmlns:a16="http://schemas.microsoft.com/office/drawing/2014/main" id="{5CA6DBF6-C77B-499F-9BE0-AEBDF8341F68}"/>
+                <a16:creationId xmlns:a16="http://schemas.microsoft.com/office/drawing/2014/main" id="{267CF3C1-A519-4624-B9B6-B16480CB5025}"/>
               </a:ext>
             </a:extLst>
           </p:cNvPr>
@@ -7595,7 +7595,7 @@
           <p:nvPr/>
         </p:nvPicPr>
         <p:blipFill>
-          <a:blip xmlns:r="http://schemas.openxmlformats.org/officeDocument/2006/relationships" xmlns:a="http://schemas.openxmlformats.org/drawingml/2006/main" r:embed="Raf37ad1f58604688">
+          <a:blip xmlns:r="http://schemas.openxmlformats.org/officeDocument/2006/relationships" xmlns:a="http://schemas.openxmlformats.org/drawingml/2006/main" r:embed="R76ef2d99983840b6">
             <a:alphaModFix/>
           </a:blip>
           <a:stretch xmlns:a="http://schemas.openxmlformats.org/drawingml/2006/main">
@@ -7620,7 +7620,7 @@
           <p:cNvPr id="142" name="Google Shape;142;p24">
             <a:extLst xmlns:a="http://schemas.openxmlformats.org/drawingml/2006/main">
               <a:ext uri="{FF2B5EF4-FFF2-40B4-BE49-F238E27FC236}">
-                <a16:creationId xmlns:a16="http://schemas.microsoft.com/office/drawing/2014/main" id="{B061A4E9-F460-4B8F-8313-D119700CEBDE}"/>
+                <a16:creationId xmlns:a16="http://schemas.microsoft.com/office/drawing/2014/main" id="{6E273217-C2F8-4BB3-A0ED-3EB136787BE9}"/>
               </a:ext>
             </a:extLst>
           </p:cNvPr>
@@ -7671,7 +7671,7 @@
           <p:cNvPr id="143" name="Google Shape;143;p24">
             <a:extLst xmlns:a="http://schemas.openxmlformats.org/drawingml/2006/main">
               <a:ext uri="{FF2B5EF4-FFF2-40B4-BE49-F238E27FC236}">
-                <a16:creationId xmlns:a16="http://schemas.microsoft.com/office/drawing/2014/main" id="{745F4C66-5672-45D8-BC54-9ED0981C6470}"/>
+                <a16:creationId xmlns:a16="http://schemas.microsoft.com/office/drawing/2014/main" id="{40E7340C-8BF7-4B4A-A2DC-1E3DCC814FFA}"/>
               </a:ext>
             </a:extLst>
           </p:cNvPr>
@@ -7729,7 +7729,7 @@
           <p:cNvPr id="144" name="">
             <a:extLst xmlns:a="http://schemas.openxmlformats.org/drawingml/2006/main">
               <a:ext uri="{FF2B5EF4-FFF2-40B4-BE49-F238E27FC236}">
-                <a16:creationId xmlns:a16="http://schemas.microsoft.com/office/drawing/2014/main" id="{6EA66C69-C238-4F49-9995-E1370A75A9FF}"/>
+                <a16:creationId xmlns:a16="http://schemas.microsoft.com/office/drawing/2014/main" id="{E1884DCC-8AF7-42ED-9282-8F357F5BA73F}"/>
               </a:ext>
             </a:extLst>
           </p:cNvPr>
@@ -7785,7 +7785,7 @@
                 <a:ea typeface="Google Sans Flex Medium"/>
                 <a:cs typeface="Google Sans Flex Medium"/>
               </a:rPr>
-              <a:t>Selected live cases: supported historical caption; contradicted caption on the same image; unresolved assertion with no evidence; source-injection attempt.</a:t>
+              <a:t>Twelve prespecified development cases: 11 expected outcomes, nine conclusive findings and three abstentions. A known false flag assertion stayed unresolved after quotation validation failed.</a:t>
             </a:r>
           </a:p>
           <a:p xmlns:a="http://schemas.openxmlformats.org/drawingml/2006/main">
@@ -7813,7 +7813,12 @@
                 <a:ea typeface="Google Sans Flex Medium"/>
                 <a:cs typeface="Google Sans Flex Medium"/>
               </a:rPr>
-              <a:t>Four exact repeats: zero additional model calls.</a:t>
+              <a:t>First pass: nine completed; three provider 429 failures. Explicit follow-ups completed all three. Twelve repeats: zero model calls.</a:t>
+            </a:r>
+          </a:p>
+          <a:p xmlns:a="http://schemas.openxmlformats.org/drawingml/2006/main">
+            <a:r>
+              <a:t/>
             </a:r>
           </a:p>
           <a:p xmlns:a="http://schemas.openxmlformats.org/drawingml/2006/main">
@@ -7836,58 +7841,7 @@
                 <a:ea typeface="Google Sans Flex Medium"/>
                 <a:cs typeface="Google Sans Flex Medium"/>
               </a:rPr>
-              <a:t>Local fresh runs: 3.3–25.9 s; local reuse: 1.0–21.0 ms.</a:t>
-            </a:r>
-          </a:p>
-          <a:p xmlns:a="http://schemas.openxmlformats.org/drawingml/2006/main">
-            <a:pPr>
-              <a:defRPr sz="1725" b="0">
-                <a:solidFill>
-                  <a:srgbClr val="202124"/>
-                </a:solidFill>
-                <a:latin typeface="Google Sans Flex Medium"/>
-                <a:ea typeface="Google Sans Flex Medium"/>
-                <a:cs typeface="Google Sans Flex Medium"/>
-              </a:defRPr>
-            </a:pPr>
-            <a:r>
-              <a:rPr sz="1725" b="0">
-                <a:solidFill>
-                  <a:srgbClr val="202124"/>
-                </a:solidFill>
-                <a:latin typeface="Google Sans Flex Medium"/>
-                <a:ea typeface="Google Sans Flex Medium"/>
-                <a:cs typeface="Google Sans Flex Medium"/>
-              </a:rPr>
-              <a:t>Hosted queued run: 10.531 s; Firestore reuse: 104.5 ms.</a:t>
-            </a:r>
-          </a:p>
-          <a:p xmlns:a="http://schemas.openxmlformats.org/drawingml/2006/main">
-            <a:r>
-              <a:t/>
-            </a:r>
-          </a:p>
-          <a:p xmlns:a="http://schemas.openxmlformats.org/drawingml/2006/main">
-            <a:pPr>
-              <a:defRPr sz="1725" b="0">
-                <a:solidFill>
-                  <a:srgbClr val="202124"/>
-                </a:solidFill>
-                <a:latin typeface="Google Sans Flex Medium"/>
-                <a:ea typeface="Google Sans Flex Medium"/>
-                <a:cs typeface="Google Sans Flex Medium"/>
-              </a:defRPr>
-            </a:pPr>
-            <a:r>
-              <a:rPr sz="1725" b="0">
-                <a:solidFill>
-                  <a:srgbClr val="202124"/>
-                </a:solidFill>
-                <a:latin typeface="Google Sans Flex Medium"/>
-                <a:ea typeface="Google Sans Flex Medium"/>
-                <a:cs typeface="Google Sans Flex Medium"/>
-              </a:rPr>
-              <a:t>36 Python + 23 JavaScript tests. Provider failures and one incidental temporal wording error are documented. No accuracy percentage is claimed.</a:t>
+              <a:t>47 Python + 27 JavaScript checks pass. Latest hosted reviewer inference hit 429 twice and failed safely. This is not representative detection accuracy.</a:t>
             </a:r>
           </a:p>
         </p:txBody>
@@ -7895,7 +7849,7 @@
     </p:spTree>
     <p:extLst>
       <p:ext uri="{BB962C8B-B14F-4D97-AF65-F5344CB8AC3E}">
-        <p14:creationId xmlns:p14="http://schemas.microsoft.com/office/powerpoint/2010/main" val="471959057"/>
+        <p14:creationId xmlns:p14="http://schemas.microsoft.com/office/powerpoint/2010/main" val="1103332677"/>
       </p:ext>
     </p:extLst>
   </p:cSld>
@@ -7919,7 +7873,7 @@
           <p:cNvPr id="148" name="Google Shape;148;p25">
             <a:extLst xmlns:a="http://schemas.openxmlformats.org/drawingml/2006/main">
               <a:ext uri="{FF2B5EF4-FFF2-40B4-BE49-F238E27FC236}">
-                <a16:creationId xmlns:a16="http://schemas.microsoft.com/office/drawing/2014/main" id="{4CC3247C-FDC6-42BD-849E-61B6A844D10A}"/>
+                <a16:creationId xmlns:a16="http://schemas.microsoft.com/office/drawing/2014/main" id="{277D166C-D941-49C7-8724-DD74E374181B}"/>
               </a:ext>
             </a:extLst>
           </p:cNvPr>
@@ -7929,7 +7883,7 @@
           <p:nvPr/>
         </p:nvPicPr>
         <p:blipFill rotWithShape="1">
-          <a:blip xmlns:r="http://schemas.openxmlformats.org/officeDocument/2006/relationships" xmlns:a="http://schemas.openxmlformats.org/drawingml/2006/main" r:embed="Rfda9fff738234e8c">
+          <a:blip xmlns:r="http://schemas.openxmlformats.org/officeDocument/2006/relationships" xmlns:a="http://schemas.openxmlformats.org/drawingml/2006/main" r:embed="R095a388ad9cb41ee">
             <a:alphaModFix/>
           </a:blip>
           <a:srcRect xmlns:a="http://schemas.openxmlformats.org/drawingml/2006/main" l="0" t="0" r="0" b="98001"/>
@@ -7953,7 +7907,7 @@
           <p:cNvPr id="149" name="Google Shape;149;p25">
             <a:extLst xmlns:a="http://schemas.openxmlformats.org/drawingml/2006/main">
               <a:ext uri="{FF2B5EF4-FFF2-40B4-BE49-F238E27FC236}">
-                <a16:creationId xmlns:a16="http://schemas.microsoft.com/office/drawing/2014/main" id="{A015126C-C1EC-4B59-93E8-7D2ED17484DB}"/>
+                <a16:creationId xmlns:a16="http://schemas.microsoft.com/office/drawing/2014/main" id="{8715723F-C2A8-4F7F-9DFD-E213585611EB}"/>
               </a:ext>
             </a:extLst>
           </p:cNvPr>
@@ -7963,7 +7917,7 @@
           <p:nvPr/>
         </p:nvPicPr>
         <p:blipFill>
-          <a:blip xmlns:r="http://schemas.openxmlformats.org/officeDocument/2006/relationships" xmlns:a="http://schemas.openxmlformats.org/drawingml/2006/main" r:embed="R21ff1874a9f44cd2">
+          <a:blip xmlns:r="http://schemas.openxmlformats.org/officeDocument/2006/relationships" xmlns:a="http://schemas.openxmlformats.org/drawingml/2006/main" r:embed="R95ea583ef1914b25">
             <a:alphaModFix/>
           </a:blip>
           <a:stretch xmlns:a="http://schemas.openxmlformats.org/drawingml/2006/main">
@@ -7988,7 +7942,7 @@
           <p:cNvPr id="150" name="Google Shape;150;p25">
             <a:extLst xmlns:a="http://schemas.openxmlformats.org/drawingml/2006/main">
               <a:ext uri="{FF2B5EF4-FFF2-40B4-BE49-F238E27FC236}">
-                <a16:creationId xmlns:a16="http://schemas.microsoft.com/office/drawing/2014/main" id="{690B2770-03E5-4C3A-90FE-AFD138BA8552}"/>
+                <a16:creationId xmlns:a16="http://schemas.microsoft.com/office/drawing/2014/main" id="{75DD29A9-E5A5-4FC5-B846-C00FA1FBF136}"/>
               </a:ext>
             </a:extLst>
           </p:cNvPr>
@@ -8039,7 +7993,7 @@
           <p:cNvPr id="151" name="Google Shape;151;p25">
             <a:extLst xmlns:a="http://schemas.openxmlformats.org/drawingml/2006/main">
               <a:ext uri="{FF2B5EF4-FFF2-40B4-BE49-F238E27FC236}">
-                <a16:creationId xmlns:a16="http://schemas.microsoft.com/office/drawing/2014/main" id="{EF2B1CF8-AD18-44B2-9719-5E15D169AB7D}"/>
+                <a16:creationId xmlns:a16="http://schemas.microsoft.com/office/drawing/2014/main" id="{72D350F6-90BE-44AE-958F-4D4F38F3B57E}"/>
               </a:ext>
             </a:extLst>
           </p:cNvPr>
@@ -8097,7 +8051,7 @@
           <p:cNvPr id="152" name="">
             <a:extLst xmlns:a="http://schemas.openxmlformats.org/drawingml/2006/main">
               <a:ext uri="{FF2B5EF4-FFF2-40B4-BE49-F238E27FC236}">
-                <a16:creationId xmlns:a16="http://schemas.microsoft.com/office/drawing/2014/main" id="{901CBF2C-0A4A-4405-A394-825705767D84}"/>
+                <a16:creationId xmlns:a16="http://schemas.microsoft.com/office/drawing/2014/main" id="{F3E8ABCE-6878-474F-89FC-70E914DE70C1}"/>
               </a:ext>
             </a:extLst>
           </p:cNvPr>
@@ -8153,7 +8107,7 @@
                 <a:ea typeface="Google Sans Flex Medium"/>
                 <a:cs typeface="Google Sans Flex Medium"/>
               </a:rPr>
-              <a:t>Current limits: X and single-image posts only. No watermark detector, C2PA validation, video analysis or semantic claim reuse.</a:t>
+              <a:t>Next rail slice: a stable API contract, small SDK and MCP adapter, with explicit permission for paid investigations. Not implemented yet.</a:t>
             </a:r>
           </a:p>
           <a:p xmlns:a="http://schemas.openxmlformats.org/drawingml/2006/main">
@@ -8181,7 +8135,7 @@
                 <a:ea typeface="Google Sans Flex Medium"/>
                 <a:cs typeface="Google Sans Flex Medium"/>
               </a:rPr>
-              <a:t>Same-model critique can miss mistakes; report links and explicit uncertainty remain essential.</a:t>
+              <a:t>A pilot needs tenant isolation, revocable access, report revisions, contribution review and capacity monitoring.</a:t>
             </a:r>
           </a:p>
           <a:p xmlns:a="http://schemas.openxmlformats.org/drawingml/2006/main">
@@ -8209,7 +8163,7 @@
                 <a:ea typeface="Google Sans Flex Medium"/>
                 <a:cs typeface="Google Sans Flex Medium"/>
               </a:rPr>
-              <a:t>Next work: larger labeled evaluation with independent reviewers, broader logged-in X coverage, fingerprint-only lookup and an Instagram-specific adapter.</a:t>
+              <a:t>Current limits: single-image X adapter; no Instagram adapter, video analysis, watermark detector or independent fact verification.</a:t>
             </a:r>
           </a:p>
         </p:txBody>
@@ -8217,7 +8171,7 @@
     </p:spTree>
     <p:extLst>
       <p:ext uri="{BB962C8B-B14F-4D97-AF65-F5344CB8AC3E}">
-        <p14:creationId xmlns:p14="http://schemas.microsoft.com/office/powerpoint/2010/main" val="1488561357"/>
+        <p14:creationId xmlns:p14="http://schemas.microsoft.com/office/powerpoint/2010/main" val="275312773"/>
       </p:ext>
     </p:extLst>
   </p:cSld>
@@ -8241,7 +8195,7 @@
           <p:cNvPr id="156" name="Google Shape;156;p26">
             <a:extLst xmlns:a="http://schemas.openxmlformats.org/drawingml/2006/main">
               <a:ext uri="{FF2B5EF4-FFF2-40B4-BE49-F238E27FC236}">
-                <a16:creationId xmlns:a16="http://schemas.microsoft.com/office/drawing/2014/main" id="{4165D1BE-9A38-4208-AA6D-B7C932B6A023}"/>
+                <a16:creationId xmlns:a16="http://schemas.microsoft.com/office/drawing/2014/main" id="{D980823A-4258-48E9-A129-DF3DA3579033}"/>
               </a:ext>
             </a:extLst>
           </p:cNvPr>
@@ -8251,7 +8205,7 @@
           <p:nvPr/>
         </p:nvPicPr>
         <p:blipFill rotWithShape="1">
-          <a:blip xmlns:r="http://schemas.openxmlformats.org/officeDocument/2006/relationships" xmlns:a="http://schemas.openxmlformats.org/drawingml/2006/main" r:embed="R7c031c8d9484459f">
+          <a:blip xmlns:r="http://schemas.openxmlformats.org/officeDocument/2006/relationships" xmlns:a="http://schemas.openxmlformats.org/drawingml/2006/main" r:embed="R0c8e88abf7a84860">
             <a:alphaModFix/>
           </a:blip>
           <a:srcRect xmlns:a="http://schemas.openxmlformats.org/drawingml/2006/main" l="0" t="0" r="0" b="98001"/>
@@ -8275,7 +8229,7 @@
           <p:cNvPr id="157" name="Google Shape;157;p26">
             <a:extLst xmlns:a="http://schemas.openxmlformats.org/drawingml/2006/main">
               <a:ext uri="{FF2B5EF4-FFF2-40B4-BE49-F238E27FC236}">
-                <a16:creationId xmlns:a16="http://schemas.microsoft.com/office/drawing/2014/main" id="{A42F1D39-C4F7-494A-8447-F18CB340494F}"/>
+                <a16:creationId xmlns:a16="http://schemas.microsoft.com/office/drawing/2014/main" id="{D845A85E-E283-47DC-B64F-18573DC58144}"/>
               </a:ext>
             </a:extLst>
           </p:cNvPr>
@@ -8285,7 +8239,7 @@
           <p:nvPr/>
         </p:nvPicPr>
         <p:blipFill>
-          <a:blip xmlns:r="http://schemas.openxmlformats.org/officeDocument/2006/relationships" xmlns:a="http://schemas.openxmlformats.org/drawingml/2006/main" r:embed="R261ba9ca4b0a4b30">
+          <a:blip xmlns:r="http://schemas.openxmlformats.org/officeDocument/2006/relationships" xmlns:a="http://schemas.openxmlformats.org/drawingml/2006/main" r:embed="Rb6cf05ca4ead425d">
             <a:alphaModFix/>
           </a:blip>
           <a:stretch xmlns:a="http://schemas.openxmlformats.org/drawingml/2006/main">
@@ -8310,7 +8264,7 @@
           <p:cNvPr id="158" name="Google Shape;158;p26">
             <a:extLst xmlns:a="http://schemas.openxmlformats.org/drawingml/2006/main">
               <a:ext uri="{FF2B5EF4-FFF2-40B4-BE49-F238E27FC236}">
-                <a16:creationId xmlns:a16="http://schemas.microsoft.com/office/drawing/2014/main" id="{5C9FF7EA-08BA-48DD-89F2-28218F983690}"/>
+                <a16:creationId xmlns:a16="http://schemas.microsoft.com/office/drawing/2014/main" id="{75AA9F6B-7197-4CEF-9CD5-77EE036CB7CB}"/>
               </a:ext>
             </a:extLst>
           </p:cNvPr>
@@ -8361,7 +8315,7 @@
           <p:cNvPr id="159" name="Google Shape;159;p26">
             <a:extLst xmlns:a="http://schemas.openxmlformats.org/drawingml/2006/main">
               <a:ext uri="{FF2B5EF4-FFF2-40B4-BE49-F238E27FC236}">
-                <a16:creationId xmlns:a16="http://schemas.microsoft.com/office/drawing/2014/main" id="{33ECE2DE-A62C-4605-82AB-B41AB6A14D29}"/>
+                <a16:creationId xmlns:a16="http://schemas.microsoft.com/office/drawing/2014/main" id="{F6902878-8396-42F6-A14C-4C84EC39067E}"/>
               </a:ext>
             </a:extLst>
           </p:cNvPr>
@@ -8441,7 +8395,7 @@
           <p:cNvPr id="160" name="">
             <a:extLst xmlns:a="http://schemas.openxmlformats.org/drawingml/2006/main">
               <a:ext uri="{FF2B5EF4-FFF2-40B4-BE49-F238E27FC236}">
-                <a16:creationId xmlns:a16="http://schemas.microsoft.com/office/drawing/2014/main" id="{47A9E33A-7C30-49D9-8D2A-D04868D502C2}"/>
+                <a16:creationId xmlns:a16="http://schemas.microsoft.com/office/drawing/2014/main" id="{19D43A9C-3F38-4830-8123-8C6EE52AB122}"/>
               </a:ext>
             </a:extLst>
           </p:cNvPr>
@@ -8630,7 +8584,7 @@
     </p:spTree>
     <p:extLst>
       <p:ext uri="{BB962C8B-B14F-4D97-AF65-F5344CB8AC3E}">
-        <p14:creationId xmlns:p14="http://schemas.microsoft.com/office/powerpoint/2010/main" val="1739649861"/>
+        <p14:creationId xmlns:p14="http://schemas.microsoft.com/office/powerpoint/2010/main" val="950750161"/>
       </p:ext>
     </p:extLst>
   </p:cSld>
@@ -8654,7 +8608,7 @@
           <p:cNvPr id="164" name="Google Shape;164;p27">
             <a:extLst xmlns:a="http://schemas.openxmlformats.org/drawingml/2006/main">
               <a:ext uri="{FF2B5EF4-FFF2-40B4-BE49-F238E27FC236}">
-                <a16:creationId xmlns:a16="http://schemas.microsoft.com/office/drawing/2014/main" id="{827CA199-1F38-4CB9-B1AE-F44592401592}"/>
+                <a16:creationId xmlns:a16="http://schemas.microsoft.com/office/drawing/2014/main" id="{72E69D79-6482-49FE-B079-9097646E0A02}"/>
               </a:ext>
             </a:extLst>
           </p:cNvPr>
@@ -8664,7 +8618,7 @@
           <p:nvPr/>
         </p:nvPicPr>
         <p:blipFill rotWithShape="1">
-          <a:blip xmlns:r="http://schemas.openxmlformats.org/officeDocument/2006/relationships" xmlns:a="http://schemas.openxmlformats.org/drawingml/2006/main" r:embed="R9df456b15bbd4178">
+          <a:blip xmlns:r="http://schemas.openxmlformats.org/officeDocument/2006/relationships" xmlns:a="http://schemas.openxmlformats.org/drawingml/2006/main" r:embed="R89029562fc6f4f1a">
             <a:alphaModFix/>
           </a:blip>
           <a:srcRect xmlns:a="http://schemas.openxmlformats.org/drawingml/2006/main" l="0" t="0" r="0" b="98001"/>
@@ -8688,7 +8642,7 @@
           <p:cNvPr id="165" name="Google Shape;165;p27">
             <a:extLst xmlns:a="http://schemas.openxmlformats.org/drawingml/2006/main">
               <a:ext uri="{FF2B5EF4-FFF2-40B4-BE49-F238E27FC236}">
-                <a16:creationId xmlns:a16="http://schemas.microsoft.com/office/drawing/2014/main" id="{4E476057-B083-456B-B772-E5E8ABA2AE23}"/>
+                <a16:creationId xmlns:a16="http://schemas.microsoft.com/office/drawing/2014/main" id="{A3B60498-3AD4-4E0A-9287-B24675537A47}"/>
               </a:ext>
             </a:extLst>
           </p:cNvPr>
@@ -8698,7 +8652,7 @@
           <p:nvPr/>
         </p:nvPicPr>
         <p:blipFill>
-          <a:blip xmlns:r="http://schemas.openxmlformats.org/officeDocument/2006/relationships" xmlns:a="http://schemas.openxmlformats.org/drawingml/2006/main" r:embed="R3a47c160aa824d70">
+          <a:blip xmlns:r="http://schemas.openxmlformats.org/officeDocument/2006/relationships" xmlns:a="http://schemas.openxmlformats.org/drawingml/2006/main" r:embed="R836453d5d73647aa">
             <a:alphaModFix/>
           </a:blip>
           <a:stretch xmlns:a="http://schemas.openxmlformats.org/drawingml/2006/main">
@@ -8723,7 +8677,7 @@
           <p:cNvPr id="166" name="Google Shape;166;p27">
             <a:extLst xmlns:a="http://schemas.openxmlformats.org/drawingml/2006/main">
               <a:ext uri="{FF2B5EF4-FFF2-40B4-BE49-F238E27FC236}">
-                <a16:creationId xmlns:a16="http://schemas.microsoft.com/office/drawing/2014/main" id="{9AB4E867-B0D8-4373-8ED3-BA4C6BA73795}"/>
+                <a16:creationId xmlns:a16="http://schemas.microsoft.com/office/drawing/2014/main" id="{9D29ED05-297E-42B0-B87F-87CA9C330E22}"/>
               </a:ext>
             </a:extLst>
           </p:cNvPr>
@@ -8774,7 +8728,7 @@
           <p:cNvPr id="167" name="">
             <a:extLst xmlns:a="http://schemas.openxmlformats.org/drawingml/2006/main">
               <a:ext uri="{FF2B5EF4-FFF2-40B4-BE49-F238E27FC236}">
-                <a16:creationId xmlns:a16="http://schemas.microsoft.com/office/drawing/2014/main" id="{206DDB4F-34D6-49C6-A25B-617DF0F91803}"/>
+                <a16:creationId xmlns:a16="http://schemas.microsoft.com/office/drawing/2014/main" id="{FB3B964A-EF67-4416-90EC-BBF27B57F1B4}"/>
               </a:ext>
             </a:extLst>
           </p:cNvPr>
@@ -8840,7 +8794,7 @@
           <p:cNvPr id="168" name="">
             <a:extLst xmlns:a="http://schemas.openxmlformats.org/drawingml/2006/main">
               <a:ext uri="{FF2B5EF4-FFF2-40B4-BE49-F238E27FC236}">
-                <a16:creationId xmlns:a16="http://schemas.microsoft.com/office/drawing/2014/main" id="{EDF981EE-37BA-4015-9644-5AF1B18CB021}"/>
+                <a16:creationId xmlns:a16="http://schemas.microsoft.com/office/drawing/2014/main" id="{98CB347C-9C08-46A5-A903-2332C9633BB9}"/>
               </a:ext>
             </a:extLst>
           </p:cNvPr>
@@ -8896,7 +8850,7 @@
                 <a:ea typeface="Google Sans Flex Medium"/>
                 <a:cs typeface="Google Sans Flex Medium"/>
               </a:rPr>
-              <a:t>Primary historical reference</a:t>
+              <a:t>Primary references: NASA Earthrise, ISRO Chandrayaan-3, National Capital Authority and the European Union flag page.</a:t>
             </a:r>
           </a:p>
           <a:p xmlns:a="http://schemas.openxmlformats.org/drawingml/2006/main">
@@ -8919,7 +8873,12 @@
                 <a:ea typeface="Google Sans Flex Medium"/>
                 <a:cs typeface="Google Sans Flex Medium"/>
               </a:rPr>
-              <a:t>science.nasa.gov/resource/apollo-8s-iconic-earthrise/</a:t>
+              <a:t>Earthrise image credit: NASA/Bill Anders; no endorsement.</a:t>
+            </a:r>
+          </a:p>
+          <a:p xmlns:a="http://schemas.openxmlformats.org/drawingml/2006/main">
+            <a:r>
+              <a:t/>
             </a:r>
           </a:p>
           <a:p xmlns:a="http://schemas.openxmlformats.org/drawingml/2006/main">
@@ -8942,7 +8901,7 @@
                 <a:ea typeface="Google Sans Flex Medium"/>
                 <a:cs typeface="Google Sans Flex Medium"/>
               </a:rPr>
-              <a:t>Image credit: NASA/Bill Anders; educational example, no endorsement.</a:t>
+              <a:t>Public samples are actual v0.4 recorded outputs. Earlier model errors and provider failures remain documented. Viewing a recorded case makes no inference calls.</a:t>
             </a:r>
           </a:p>
           <a:p xmlns:a="http://schemas.openxmlformats.org/drawingml/2006/main">
@@ -8970,58 +8929,7 @@
                 <a:ea typeface="Google Sans Flex Medium"/>
                 <a:cs typeface="Google Sans Flex Medium"/>
               </a:rPr>
-              <a:t>AI assessments are ProofMesh outputs. The misleading-caption recorded case includes a QA note identifying an incidental mission-date wording error.</a:t>
-            </a:r>
-          </a:p>
-          <a:p xmlns:a="http://schemas.openxmlformats.org/drawingml/2006/main">
-            <a:r>
-              <a:t/>
-            </a:r>
-          </a:p>
-          <a:p xmlns:a="http://schemas.openxmlformats.org/drawingml/2006/main">
-            <a:pPr>
-              <a:defRPr sz="1725" b="0">
-                <a:solidFill>
-                  <a:srgbClr val="202124"/>
-                </a:solidFill>
-                <a:latin typeface="Google Sans Flex Medium"/>
-                <a:ea typeface="Google Sans Flex Medium"/>
-                <a:cs typeface="Google Sans Flex Medium"/>
-              </a:defRPr>
-            </a:pPr>
-            <a:r>
-              <a:rPr sz="1725" b="0">
-                <a:solidFill>
-                  <a:srgbClr val="202124"/>
-                </a:solidFill>
-                <a:latin typeface="Google Sans Flex Medium"/>
-                <a:ea typeface="Google Sans Flex Medium"/>
-                <a:cs typeface="Google Sans Flex Medium"/>
-              </a:rPr>
-              <a:t>Full methodology and limits: docs/EVALUATION.md in the repository.</a:t>
-            </a:r>
-          </a:p>
-          <a:p xmlns:a="http://schemas.openxmlformats.org/drawingml/2006/main">
-            <a:pPr>
-              <a:defRPr sz="1725" b="0">
-                <a:solidFill>
-                  <a:srgbClr val="202124"/>
-                </a:solidFill>
-                <a:latin typeface="Google Sans Flex Medium"/>
-                <a:ea typeface="Google Sans Flex Medium"/>
-                <a:cs typeface="Google Sans Flex Medium"/>
-              </a:defRPr>
-            </a:pPr>
-            <a:r>
-              <a:rPr sz="1725" b="0">
-                <a:solidFill>
-                  <a:srgbClr val="202124"/>
-                </a:solidFill>
-                <a:latin typeface="Google Sans Flex Medium"/>
-                <a:ea typeface="Google Sans Flex Medium"/>
-                <a:cs typeface="Google Sans Flex Medium"/>
-              </a:rPr>
-              <a:t>Public cases are recorded runs; viewing them makes no inference calls.</a:t>
+              <a:t>Method, case labels and limits: docs/EVALUATION.md and evaluation/results-v04.json in the repository.</a:t>
             </a:r>
           </a:p>
         </p:txBody>
@@ -9029,7 +8937,7 @@
     </p:spTree>
     <p:extLst>
       <p:ext uri="{BB962C8B-B14F-4D97-AF65-F5344CB8AC3E}">
-        <p14:creationId xmlns:p14="http://schemas.microsoft.com/office/powerpoint/2010/main" val="1893665438"/>
+        <p14:creationId xmlns:p14="http://schemas.microsoft.com/office/powerpoint/2010/main" val="1732458910"/>
       </p:ext>
     </p:extLst>
   </p:cSld>
@@ -9053,7 +8961,7 @@
           <p:cNvPr id="171" name="Google Shape;171;p28">
             <a:extLst xmlns:a="http://schemas.openxmlformats.org/drawingml/2006/main">
               <a:ext uri="{FF2B5EF4-FFF2-40B4-BE49-F238E27FC236}">
-                <a16:creationId xmlns:a16="http://schemas.microsoft.com/office/drawing/2014/main" id="{80549C8D-627C-4EEA-9287-C8CBCB76A715}"/>
+                <a16:creationId xmlns:a16="http://schemas.microsoft.com/office/drawing/2014/main" id="{823DE6A5-4B23-4EF0-ABFC-C8A651107678}"/>
               </a:ext>
             </a:extLst>
           </p:cNvPr>
@@ -9063,7 +8971,7 @@
           <p:nvPr/>
         </p:nvPicPr>
         <p:blipFill rotWithShape="1">
-          <a:blip xmlns:r="http://schemas.openxmlformats.org/officeDocument/2006/relationships" xmlns:a="http://schemas.openxmlformats.org/drawingml/2006/main" r:embed="Rab63c8f9768c4d3c">
+          <a:blip xmlns:r="http://schemas.openxmlformats.org/officeDocument/2006/relationships" xmlns:a="http://schemas.openxmlformats.org/drawingml/2006/main" r:embed="Rbd36d59dd8a34779">
             <a:alphaModFix/>
           </a:blip>
           <a:srcRect xmlns:a="http://schemas.openxmlformats.org/drawingml/2006/main" l="0" t="0" r="0" b="98001"/>
@@ -9087,7 +8995,7 @@
           <p:cNvPr id="172" name="Google Shape;172;p28">
             <a:extLst xmlns:a="http://schemas.openxmlformats.org/drawingml/2006/main">
               <a:ext uri="{FF2B5EF4-FFF2-40B4-BE49-F238E27FC236}">
-                <a16:creationId xmlns:a16="http://schemas.microsoft.com/office/drawing/2014/main" id="{35B7CAA3-4474-4EF3-A043-51E9D5A720F4}"/>
+                <a16:creationId xmlns:a16="http://schemas.microsoft.com/office/drawing/2014/main" id="{14882CE3-A6EF-41E8-903E-69CA1965AC26}"/>
               </a:ext>
             </a:extLst>
           </p:cNvPr>
@@ -9097,7 +9005,7 @@
           <p:nvPr/>
         </p:nvPicPr>
         <p:blipFill>
-          <a:blip xmlns:r="http://schemas.openxmlformats.org/officeDocument/2006/relationships" xmlns:a="http://schemas.openxmlformats.org/drawingml/2006/main" r:embed="R803265f5be494211">
+          <a:blip xmlns:r="http://schemas.openxmlformats.org/officeDocument/2006/relationships" xmlns:a="http://schemas.openxmlformats.org/drawingml/2006/main" r:embed="Rd7bf4ee57cad41d4">
             <a:alphaModFix/>
           </a:blip>
           <a:stretch xmlns:a="http://schemas.openxmlformats.org/drawingml/2006/main">
@@ -9120,7 +9028,7 @@
     </p:spTree>
     <p:extLst>
       <p:ext uri="{BB962C8B-B14F-4D97-AF65-F5344CB8AC3E}">
-        <p14:creationId xmlns:p14="http://schemas.microsoft.com/office/powerpoint/2010/main" val="1698923537"/>
+        <p14:creationId xmlns:p14="http://schemas.microsoft.com/office/powerpoint/2010/main" val="706169072"/>
       </p:ext>
     </p:extLst>
   </p:cSld>
@@ -9144,7 +9052,7 @@
           <p:cNvPr id="69" name="Google Shape;69;p15">
             <a:extLst xmlns:a="http://schemas.openxmlformats.org/drawingml/2006/main">
               <a:ext uri="{FF2B5EF4-FFF2-40B4-BE49-F238E27FC236}">
-                <a16:creationId xmlns:a16="http://schemas.microsoft.com/office/drawing/2014/main" id="{B2CD953B-68D6-4D41-BD3C-4309D3F430B5}"/>
+                <a16:creationId xmlns:a16="http://schemas.microsoft.com/office/drawing/2014/main" id="{A8ABDF4F-1B7E-4133-A8C6-A04A923287DE}"/>
               </a:ext>
             </a:extLst>
           </p:cNvPr>
@@ -9154,7 +9062,7 @@
           <p:nvPr/>
         </p:nvPicPr>
         <p:blipFill>
-          <a:blip xmlns:r="http://schemas.openxmlformats.org/officeDocument/2006/relationships" xmlns:a="http://schemas.openxmlformats.org/drawingml/2006/main" r:embed="R1c818d4234e34c8b">
+          <a:blip xmlns:r="http://schemas.openxmlformats.org/officeDocument/2006/relationships" xmlns:a="http://schemas.openxmlformats.org/drawingml/2006/main" r:embed="R2d21f02ed3934912">
             <a:alphaModFix/>
           </a:blip>
           <a:stretch xmlns:a="http://schemas.openxmlformats.org/drawingml/2006/main">
@@ -9179,7 +9087,7 @@
           <p:cNvPr id="70" name="Google Shape;70;p15">
             <a:extLst xmlns:a="http://schemas.openxmlformats.org/drawingml/2006/main">
               <a:ext uri="{FF2B5EF4-FFF2-40B4-BE49-F238E27FC236}">
-                <a16:creationId xmlns:a16="http://schemas.microsoft.com/office/drawing/2014/main" id="{458358E1-00C7-4899-A5EF-C4E49A3BE952}"/>
+                <a16:creationId xmlns:a16="http://schemas.microsoft.com/office/drawing/2014/main" id="{12AC871A-131C-4458-9322-8FEA57DDF5CC}"/>
               </a:ext>
             </a:extLst>
           </p:cNvPr>
@@ -9230,7 +9138,7 @@
           <p:cNvPr id="71" name="Google Shape;71;p15">
             <a:extLst xmlns:a="http://schemas.openxmlformats.org/drawingml/2006/main">
               <a:ext uri="{FF2B5EF4-FFF2-40B4-BE49-F238E27FC236}">
-                <a16:creationId xmlns:a16="http://schemas.microsoft.com/office/drawing/2014/main" id="{D34CE9B6-8857-4F33-BF1C-540D5D04434C}"/>
+                <a16:creationId xmlns:a16="http://schemas.microsoft.com/office/drawing/2014/main" id="{FC5FB30D-F974-4B98-9379-AE70B0F7E612}"/>
               </a:ext>
             </a:extLst>
           </p:cNvPr>
@@ -9288,7 +9196,7 @@
           <p:cNvPr id="72" name="">
             <a:extLst xmlns:a="http://schemas.openxmlformats.org/drawingml/2006/main">
               <a:ext uri="{FF2B5EF4-FFF2-40B4-BE49-F238E27FC236}">
-                <a16:creationId xmlns:a16="http://schemas.microsoft.com/office/drawing/2014/main" id="{2213220D-8218-4636-A082-DB410A6E5913}"/>
+                <a16:creationId xmlns:a16="http://schemas.microsoft.com/office/drawing/2014/main" id="{2F64DAE1-4D01-4D6B-89CD-4464E6DC442F}"/>
               </a:ext>
             </a:extLst>
           </p:cNvPr>
@@ -9314,7 +9222,7 @@
           <a:bodyPr xmlns:a="http://schemas.openxmlformats.org/drawingml/2006/main"/>
           <a:lstStyle xmlns:a="http://schemas.openxmlformats.org/drawingml/2006/main">
             <a:defPPr>
-              <a:defRPr sz="1950" b="0">
+              <a:defRPr sz="1875" b="0">
                 <a:solidFill>
                   <a:srgbClr val="202124"/>
                 </a:solidFill>
@@ -9326,7 +9234,7 @@
           </a:lstStyle>
           <a:p xmlns:a="http://schemas.openxmlformats.org/drawingml/2006/main">
             <a:pPr>
-              <a:defRPr sz="1950" b="0">
+              <a:defRPr sz="1875" b="0">
                 <a:solidFill>
                   <a:srgbClr val="202124"/>
                 </a:solidFill>
@@ -9336,7 +9244,7 @@
               </a:defRPr>
             </a:pPr>
             <a:r>
-              <a:rPr sz="1950" b="0">
+              <a:rPr sz="1875" b="0">
                 <a:solidFill>
                   <a:srgbClr val="202124"/>
                 </a:solidFill>
@@ -9344,7 +9252,7 @@
                 <a:ea typeface="Google Sans Flex Medium"/>
                 <a:cs typeface="Google Sans Flex Medium"/>
               </a:rPr>
-              <a:t>ProofMesh separates the identity of an image from the claims made about it.</a:t>
+              <a:t>The rail keeps media identity separate from what a caption claims.</a:t>
             </a:r>
           </a:p>
           <a:p xmlns:a="http://schemas.openxmlformats.org/drawingml/2006/main">
@@ -9354,7 +9262,7 @@
           </a:p>
           <a:p xmlns:a="http://schemas.openxmlformats.org/drawingml/2006/main">
             <a:pPr>
-              <a:defRPr sz="1950" b="0">
+              <a:defRPr sz="1875" b="0">
                 <a:solidFill>
                   <a:srgbClr val="202124"/>
                 </a:solidFill>
@@ -9364,7 +9272,7 @@
               </a:defRPr>
             </a:pPr>
             <a:r>
-              <a:rPr sz="1950" b="0">
+              <a:rPr sz="1875" b="0">
                 <a:solidFill>
                   <a:srgbClr val="202124"/>
                 </a:solidFill>
@@ -9372,7 +9280,7 @@
                 <a:ea typeface="Google Sans Flex Medium"/>
                 <a:cs typeface="Google Sans Flex Medium"/>
               </a:rPr>
-              <a:t>The Chrome extension checks visible X posts against a shared investigation registry. A familiar image with a different caption stays unverified.</a:t>
+              <a:t>The web workspace and X extension are its first API clients. Both can retrieve stored evidence; new claims can start durable Google Cloud jobs.</a:t>
             </a:r>
           </a:p>
           <a:p xmlns:a="http://schemas.openxmlformats.org/drawingml/2006/main">
@@ -9382,7 +9290,7 @@
           </a:p>
           <a:p xmlns:a="http://schemas.openxmlformats.org/drawingml/2006/main">
             <a:pPr>
-              <a:defRPr sz="1950" b="0">
+              <a:defRPr sz="1875" b="0">
                 <a:solidFill>
                   <a:srgbClr val="202124"/>
                 </a:solidFill>
@@ -9392,7 +9300,7 @@
               </a:defRPr>
             </a:pPr>
             <a:r>
-              <a:rPr sz="1950" b="0">
+              <a:rPr sz="1875" b="0">
                 <a:solidFill>
                   <a:srgbClr val="202124"/>
                 </a:solidFill>
@@ -9400,7 +9308,7 @@
                 <a:ea typeface="Google Sans Flex Medium"/>
                 <a:cs typeface="Google Sans Flex Medium"/>
               </a:rPr>
-              <a:t>On demand, Gemini researches the exact claim, assesses fetched source passages and critiques its conclusion. Media origin remains unknown.</a:t>
+              <a:t>Gemini assesses fetched source quotations and critiques conclusions. Uncertain evidence stays unresolved; media origin remains unknown.</a:t>
             </a:r>
           </a:p>
         </p:txBody>
@@ -9408,7 +9316,7 @@
     </p:spTree>
     <p:extLst>
       <p:ext uri="{BB962C8B-B14F-4D97-AF65-F5344CB8AC3E}">
-        <p14:creationId xmlns:p14="http://schemas.microsoft.com/office/powerpoint/2010/main" val="2041116335"/>
+        <p14:creationId xmlns:p14="http://schemas.microsoft.com/office/powerpoint/2010/main" val="103865794"/>
       </p:ext>
     </p:extLst>
   </p:cSld>
@@ -9432,7 +9340,7 @@
           <p:cNvPr id="76" name="Google Shape;76;p16">
             <a:extLst xmlns:a="http://schemas.openxmlformats.org/drawingml/2006/main">
               <a:ext uri="{FF2B5EF4-FFF2-40B4-BE49-F238E27FC236}">
-                <a16:creationId xmlns:a16="http://schemas.microsoft.com/office/drawing/2014/main" id="{FDC2DCC2-1741-4D14-BA09-25A5A36BC11D}"/>
+                <a16:creationId xmlns:a16="http://schemas.microsoft.com/office/drawing/2014/main" id="{8BBDBC80-0BFB-49F7-956C-74450BA1ED74}"/>
               </a:ext>
             </a:extLst>
           </p:cNvPr>
@@ -9442,7 +9350,7 @@
           <p:nvPr/>
         </p:nvPicPr>
         <p:blipFill rotWithShape="1">
-          <a:blip xmlns:r="http://schemas.openxmlformats.org/officeDocument/2006/relationships" xmlns:a="http://schemas.openxmlformats.org/drawingml/2006/main" r:embed="R2781458ac20a42e3">
+          <a:blip xmlns:r="http://schemas.openxmlformats.org/officeDocument/2006/relationships" xmlns:a="http://schemas.openxmlformats.org/drawingml/2006/main" r:embed="Rd276c49a8b254a3b">
             <a:alphaModFix/>
           </a:blip>
           <a:srcRect xmlns:a="http://schemas.openxmlformats.org/drawingml/2006/main" l="0" t="0" r="0" b="98001"/>
@@ -9466,7 +9374,7 @@
           <p:cNvPr id="77" name="Google Shape;77;p16">
             <a:extLst xmlns:a="http://schemas.openxmlformats.org/drawingml/2006/main">
               <a:ext uri="{FF2B5EF4-FFF2-40B4-BE49-F238E27FC236}">
-                <a16:creationId xmlns:a16="http://schemas.microsoft.com/office/drawing/2014/main" id="{AC8924EC-2A7B-40FA-9590-F1CC961E8F3D}"/>
+                <a16:creationId xmlns:a16="http://schemas.microsoft.com/office/drawing/2014/main" id="{5C7720D5-C4AD-4070-9262-596648FD6A30}"/>
               </a:ext>
             </a:extLst>
           </p:cNvPr>
@@ -9476,7 +9384,7 @@
           <p:nvPr/>
         </p:nvPicPr>
         <p:blipFill>
-          <a:blip xmlns:r="http://schemas.openxmlformats.org/officeDocument/2006/relationships" xmlns:a="http://schemas.openxmlformats.org/drawingml/2006/main" r:embed="Rf876271ac1af4cbb">
+          <a:blip xmlns:r="http://schemas.openxmlformats.org/officeDocument/2006/relationships" xmlns:a="http://schemas.openxmlformats.org/drawingml/2006/main" r:embed="R9da6e8b9c7034687">
             <a:alphaModFix/>
           </a:blip>
           <a:stretch xmlns:a="http://schemas.openxmlformats.org/drawingml/2006/main">
@@ -9501,7 +9409,7 @@
           <p:cNvPr id="78" name="Google Shape;78;p16">
             <a:extLst xmlns:a="http://schemas.openxmlformats.org/drawingml/2006/main">
               <a:ext uri="{FF2B5EF4-FFF2-40B4-BE49-F238E27FC236}">
-                <a16:creationId xmlns:a16="http://schemas.microsoft.com/office/drawing/2014/main" id="{C0AA6DA2-F756-45AC-A9C3-29F637CBC385}"/>
+                <a16:creationId xmlns:a16="http://schemas.microsoft.com/office/drawing/2014/main" id="{66EA6AEF-46C0-474B-8208-303473E5EC84}"/>
               </a:ext>
             </a:extLst>
           </p:cNvPr>
@@ -9552,7 +9460,7 @@
           <p:cNvPr id="79" name="Google Shape;79;p16">
             <a:extLst xmlns:a="http://schemas.openxmlformats.org/drawingml/2006/main">
               <a:ext uri="{FF2B5EF4-FFF2-40B4-BE49-F238E27FC236}">
-                <a16:creationId xmlns:a16="http://schemas.microsoft.com/office/drawing/2014/main" id="{6408E005-D9D2-44D9-A8FB-DD0354E03593}"/>
+                <a16:creationId xmlns:a16="http://schemas.microsoft.com/office/drawing/2014/main" id="{CE9D6201-979C-49C9-B608-901C907C4DF8}"/>
               </a:ext>
             </a:extLst>
           </p:cNvPr>
@@ -9632,7 +9540,7 @@
           <p:cNvPr id="80" name="">
             <a:extLst xmlns:a="http://schemas.openxmlformats.org/drawingml/2006/main">
               <a:ext uri="{FF2B5EF4-FFF2-40B4-BE49-F238E27FC236}">
-                <a16:creationId xmlns:a16="http://schemas.microsoft.com/office/drawing/2014/main" id="{AD58F592-56ED-46AC-8C7F-65990CF22873}"/>
+                <a16:creationId xmlns:a16="http://schemas.microsoft.com/office/drawing/2014/main" id="{AB36BCFB-D2AD-41DD-A0F5-3BA9FF57FFE9}"/>
               </a:ext>
             </a:extLst>
           </p:cNvPr>
@@ -9688,7 +9596,7 @@
                 <a:ea typeface="Google Sans Flex Medium"/>
                 <a:cs typeface="Google Sans Flex Medium"/>
               </a:rPr>
-              <a:t>Difference: completed investigations become reusable context in the browsing feed, rather than a one-off chat response.</a:t>
+              <a:t>Reusable infrastructure: an investigation should be available wherever the same claim appears, with its context and limitations intact.</a:t>
             </a:r>
           </a:p>
           <a:p xmlns:a="http://schemas.openxmlformats.org/drawingml/2006/main">
@@ -9716,7 +9624,7 @@
                 <a:ea typeface="Google Sans Flex Medium"/>
                 <a:cs typeface="Google Sans Flex Medium"/>
               </a:rPr>
-              <a:t>Problem addressed: authentic media can be assigned a misleading date, location or event. Each caption needs its own evidence.</a:t>
+              <a:t>Current clients: the web workspace and X extension.</a:t>
             </a:r>
           </a:p>
           <a:p xmlns:a="http://schemas.openxmlformats.org/drawingml/2006/main">
@@ -9744,7 +9652,7 @@
                 <a:ea typeface="Google Sans Flex Medium"/>
                 <a:cs typeface="Google Sans Flex Medium"/>
               </a:rPr>
-              <a:t>USP: exact-context reuse makes zero model calls. Similar images retrieve leads, never an inherited verdict.</a:t>
+              <a:t>Future consumers could include social apps, Android/Gemini experiences and agents through an MCP adapter. These are proposals, not existing integrations or partnerships.</a:t>
             </a:r>
           </a:p>
         </p:txBody>
@@ -9752,7 +9660,7 @@
     </p:spTree>
     <p:extLst>
       <p:ext uri="{BB962C8B-B14F-4D97-AF65-F5344CB8AC3E}">
-        <p14:creationId xmlns:p14="http://schemas.microsoft.com/office/powerpoint/2010/main" val="730882826"/>
+        <p14:creationId xmlns:p14="http://schemas.microsoft.com/office/powerpoint/2010/main" val="1257922330"/>
       </p:ext>
     </p:extLst>
   </p:cSld>
@@ -9776,7 +9684,7 @@
           <p:cNvPr id="84" name="Google Shape;84;p17">
             <a:extLst xmlns:a="http://schemas.openxmlformats.org/drawingml/2006/main">
               <a:ext uri="{FF2B5EF4-FFF2-40B4-BE49-F238E27FC236}">
-                <a16:creationId xmlns:a16="http://schemas.microsoft.com/office/drawing/2014/main" id="{4165E41A-A657-4AAF-85F0-F8FAD137A575}"/>
+                <a16:creationId xmlns:a16="http://schemas.microsoft.com/office/drawing/2014/main" id="{BE9C1393-E2E1-484D-B931-A7F2B760E46B}"/>
               </a:ext>
             </a:extLst>
           </p:cNvPr>
@@ -9786,7 +9694,7 @@
           <p:nvPr/>
         </p:nvPicPr>
         <p:blipFill rotWithShape="1">
-          <a:blip xmlns:r="http://schemas.openxmlformats.org/officeDocument/2006/relationships" xmlns:a="http://schemas.openxmlformats.org/drawingml/2006/main" r:embed="R3b8c96bcccf24d51">
+          <a:blip xmlns:r="http://schemas.openxmlformats.org/officeDocument/2006/relationships" xmlns:a="http://schemas.openxmlformats.org/drawingml/2006/main" r:embed="Re046712c504f47b2">
             <a:alphaModFix/>
           </a:blip>
           <a:srcRect xmlns:a="http://schemas.openxmlformats.org/drawingml/2006/main" l="0" t="0" r="0" b="98001"/>
@@ -9810,7 +9718,7 @@
           <p:cNvPr id="85" name="Google Shape;85;p17">
             <a:extLst xmlns:a="http://schemas.openxmlformats.org/drawingml/2006/main">
               <a:ext uri="{FF2B5EF4-FFF2-40B4-BE49-F238E27FC236}">
-                <a16:creationId xmlns:a16="http://schemas.microsoft.com/office/drawing/2014/main" id="{1328A7E3-BDC5-4C2D-80BE-D6090843F6FA}"/>
+                <a16:creationId xmlns:a16="http://schemas.microsoft.com/office/drawing/2014/main" id="{3E101450-A292-45B8-B198-AFE786620D38}"/>
               </a:ext>
             </a:extLst>
           </p:cNvPr>
@@ -9820,7 +9728,7 @@
           <p:nvPr/>
         </p:nvPicPr>
         <p:blipFill>
-          <a:blip xmlns:r="http://schemas.openxmlformats.org/officeDocument/2006/relationships" xmlns:a="http://schemas.openxmlformats.org/drawingml/2006/main" r:embed="R49d48356ea754a5a">
+          <a:blip xmlns:r="http://schemas.openxmlformats.org/officeDocument/2006/relationships" xmlns:a="http://schemas.openxmlformats.org/drawingml/2006/main" r:embed="Rd8c66f8182734b3e">
             <a:alphaModFix/>
           </a:blip>
           <a:stretch xmlns:a="http://schemas.openxmlformats.org/drawingml/2006/main">
@@ -9845,7 +9753,7 @@
           <p:cNvPr id="86" name="Google Shape;86;p17">
             <a:extLst xmlns:a="http://schemas.openxmlformats.org/drawingml/2006/main">
               <a:ext uri="{FF2B5EF4-FFF2-40B4-BE49-F238E27FC236}">
-                <a16:creationId xmlns:a16="http://schemas.microsoft.com/office/drawing/2014/main" id="{4A4FB6FF-644D-4A56-8BC1-E6B6C838D6AA}"/>
+                <a16:creationId xmlns:a16="http://schemas.microsoft.com/office/drawing/2014/main" id="{238209E2-389D-4E4E-A19F-5F88F63D155F}"/>
               </a:ext>
             </a:extLst>
           </p:cNvPr>
@@ -9896,7 +9804,7 @@
           <p:cNvPr id="87" name="Google Shape;87;p17">
             <a:extLst xmlns:a="http://schemas.openxmlformats.org/drawingml/2006/main">
               <a:ext uri="{FF2B5EF4-FFF2-40B4-BE49-F238E27FC236}">
-                <a16:creationId xmlns:a16="http://schemas.microsoft.com/office/drawing/2014/main" id="{97A1494F-BA0B-4583-807C-4626A61D3AF2}"/>
+                <a16:creationId xmlns:a16="http://schemas.microsoft.com/office/drawing/2014/main" id="{8019590D-1605-4E23-BC5A-8F576675283E}"/>
               </a:ext>
             </a:extLst>
           </p:cNvPr>
@@ -9954,7 +9862,7 @@
           <p:cNvPr id="88" name="">
             <a:extLst xmlns:a="http://schemas.openxmlformats.org/drawingml/2006/main">
               <a:ext uri="{FF2B5EF4-FFF2-40B4-BE49-F238E27FC236}">
-                <a16:creationId xmlns:a16="http://schemas.microsoft.com/office/drawing/2014/main" id="{ED2BA232-8B69-4546-AB23-2DDF6B4232C0}"/>
+                <a16:creationId xmlns:a16="http://schemas.microsoft.com/office/drawing/2014/main" id="{01DF8010-089C-4714-9343-ED1FF609B089}"/>
               </a:ext>
             </a:extLst>
           </p:cNvPr>
@@ -10010,7 +9918,7 @@
                 <a:ea typeface="Google Sans Flex Medium"/>
                 <a:cs typeface="Google Sans Flex Medium"/>
               </a:rPr>
-              <a:t>Visible-post extraction and opt-in registry lookups on X</a:t>
+              <a:t>Shared lookup, investigation-job and report APIs</a:t>
             </a:r>
           </a:p>
           <a:p xmlns:a="http://schemas.openxmlformats.org/drawingml/2006/main">
@@ -10038,7 +9946,7 @@
                 <a:ea typeface="Google Sans Flex Medium"/>
                 <a:cs typeface="Google Sans Flex Medium"/>
               </a:rPr>
-              <a:t>Image fingerprints and separate caption identity</a:t>
+              <a:t>Exact image, caption and publication-context identity</a:t>
             </a:r>
           </a:p>
           <a:p xmlns:a="http://schemas.openxmlformats.org/drawingml/2006/main">
@@ -10066,7 +9974,7 @@
                 <a:ea typeface="Google Sans Flex Medium"/>
                 <a:cs typeface="Google Sans Flex Medium"/>
               </a:rPr>
-              <a:t>Source-linked supported, contradicted or unresolved findings</a:t>
+              <a:t>Findings with validated source quotations and context checks</a:t>
             </a:r>
           </a:p>
           <a:p xmlns:a="http://schemas.openxmlformats.org/drawingml/2006/main">
@@ -10094,7 +10002,7 @@
                 <a:ea typeface="Google Sans Flex Medium"/>
                 <a:cs typeface="Google Sans Flex Medium"/>
               </a:rPr>
-              <a:t>Persistent jobs with polling, deduplication and bounded retry</a:t>
+              <a:t>Persistent jobs and isolated reviewer access with reserved allowance</a:t>
             </a:r>
           </a:p>
           <a:p xmlns:a="http://schemas.openxmlformats.org/drawingml/2006/main">
@@ -10122,7 +10030,7 @@
                 <a:ea typeface="Google Sans Flex Medium"/>
                 <a:cs typeface="Google Sans Flex Medium"/>
               </a:rPr>
-              <a:t>Public recorded cases and downloadable evidence reports</a:t>
+              <a:t>Public recorded examples; explicit failure and uncertainty states</a:t>
             </a:r>
           </a:p>
         </p:txBody>
@@ -10130,7 +10038,7 @@
     </p:spTree>
     <p:extLst>
       <p:ext uri="{BB962C8B-B14F-4D97-AF65-F5344CB8AC3E}">
-        <p14:creationId xmlns:p14="http://schemas.microsoft.com/office/powerpoint/2010/main" val="312682881"/>
+        <p14:creationId xmlns:p14="http://schemas.microsoft.com/office/powerpoint/2010/main" val="1365906234"/>
       </p:ext>
     </p:extLst>
   </p:cSld>
@@ -10154,7 +10062,7 @@
           <p:cNvPr id="92" name="Google Shape;92;p18">
             <a:extLst xmlns:a="http://schemas.openxmlformats.org/drawingml/2006/main">
               <a:ext uri="{FF2B5EF4-FFF2-40B4-BE49-F238E27FC236}">
-                <a16:creationId xmlns:a16="http://schemas.microsoft.com/office/drawing/2014/main" id="{BDC2E2E3-1EEE-499E-AAD2-0749FDB8C16D}"/>
+                <a16:creationId xmlns:a16="http://schemas.microsoft.com/office/drawing/2014/main" id="{DED83C3F-925B-409B-8B52-06476C58888A}"/>
               </a:ext>
             </a:extLst>
           </p:cNvPr>
@@ -10164,7 +10072,7 @@
           <p:nvPr/>
         </p:nvPicPr>
         <p:blipFill rotWithShape="1">
-          <a:blip xmlns:r="http://schemas.openxmlformats.org/officeDocument/2006/relationships" xmlns:a="http://schemas.openxmlformats.org/drawingml/2006/main" r:embed="Rd104cc3be4d74d8f">
+          <a:blip xmlns:r="http://schemas.openxmlformats.org/officeDocument/2006/relationships" xmlns:a="http://schemas.openxmlformats.org/drawingml/2006/main" r:embed="R5672832a08d44f0a">
             <a:alphaModFix/>
           </a:blip>
           <a:srcRect xmlns:a="http://schemas.openxmlformats.org/drawingml/2006/main" l="0" t="0" r="0" b="98001"/>
@@ -10188,7 +10096,7 @@
           <p:cNvPr id="93" name="Google Shape;93;p18">
             <a:extLst xmlns:a="http://schemas.openxmlformats.org/drawingml/2006/main">
               <a:ext uri="{FF2B5EF4-FFF2-40B4-BE49-F238E27FC236}">
-                <a16:creationId xmlns:a16="http://schemas.microsoft.com/office/drawing/2014/main" id="{6804CB8F-589D-475F-A320-86D5EFBB1AC0}"/>
+                <a16:creationId xmlns:a16="http://schemas.microsoft.com/office/drawing/2014/main" id="{94246BDF-9809-4EE6-BDE5-D69BF9884954}"/>
               </a:ext>
             </a:extLst>
           </p:cNvPr>
@@ -10198,7 +10106,7 @@
           <p:nvPr/>
         </p:nvPicPr>
         <p:blipFill>
-          <a:blip xmlns:r="http://schemas.openxmlformats.org/officeDocument/2006/relationships" xmlns:a="http://schemas.openxmlformats.org/drawingml/2006/main" r:embed="R0ca08aee44a54507">
+          <a:blip xmlns:r="http://schemas.openxmlformats.org/officeDocument/2006/relationships" xmlns:a="http://schemas.openxmlformats.org/drawingml/2006/main" r:embed="R48153fbb448c4804">
             <a:alphaModFix/>
           </a:blip>
           <a:stretch xmlns:a="http://schemas.openxmlformats.org/drawingml/2006/main">
@@ -10223,7 +10131,7 @@
           <p:cNvPr id="94" name="Google Shape;94;p18">
             <a:extLst xmlns:a="http://schemas.openxmlformats.org/drawingml/2006/main">
               <a:ext uri="{FF2B5EF4-FFF2-40B4-BE49-F238E27FC236}">
-                <a16:creationId xmlns:a16="http://schemas.microsoft.com/office/drawing/2014/main" id="{8B376A17-CCC2-4C0D-B5C8-BF86E89657E3}"/>
+                <a16:creationId xmlns:a16="http://schemas.microsoft.com/office/drawing/2014/main" id="{8CEB7ACC-DC40-4092-B664-C2007CAC2C17}"/>
               </a:ext>
             </a:extLst>
           </p:cNvPr>
@@ -10274,7 +10182,7 @@
           <p:cNvPr id="95" name="Google Shape;95;p18">
             <a:extLst xmlns:a="http://schemas.openxmlformats.org/drawingml/2006/main">
               <a:ext uri="{FF2B5EF4-FFF2-40B4-BE49-F238E27FC236}">
-                <a16:creationId xmlns:a16="http://schemas.microsoft.com/office/drawing/2014/main" id="{8F047692-3F1F-4218-BB7D-DB8809BF439C}"/>
+                <a16:creationId xmlns:a16="http://schemas.microsoft.com/office/drawing/2014/main" id="{18BDBF18-5702-4309-B0A2-2DF6AF553E0A}"/>
               </a:ext>
             </a:extLst>
           </p:cNvPr>
@@ -10332,7 +10240,7 @@
           <p:cNvPr id="96" name="">
             <a:extLst xmlns:a="http://schemas.openxmlformats.org/drawingml/2006/main">
               <a:ext uri="{FF2B5EF4-FFF2-40B4-BE49-F238E27FC236}">
-                <a16:creationId xmlns:a16="http://schemas.microsoft.com/office/drawing/2014/main" id="{7098D5E7-F2E6-499E-B94B-C301597E45CD}"/>
+                <a16:creationId xmlns:a16="http://schemas.microsoft.com/office/drawing/2014/main" id="{3F3C957E-1D0A-4C94-94AF-833686EEBEB0}"/>
               </a:ext>
             </a:extLst>
           </p:cNvPr>
@@ -10425,7 +10333,7 @@
           <p:cNvPr id="97" name="">
             <a:extLst xmlns:a="http://schemas.openxmlformats.org/drawingml/2006/main">
               <a:ext uri="{FF2B5EF4-FFF2-40B4-BE49-F238E27FC236}">
-                <a16:creationId xmlns:a16="http://schemas.microsoft.com/office/drawing/2014/main" id="{C933D9F1-2EA2-4680-B42F-C6D68D0E9E06}"/>
+                <a16:creationId xmlns:a16="http://schemas.microsoft.com/office/drawing/2014/main" id="{D46C1428-B57A-4B1F-B53A-53E791ADFD90}"/>
               </a:ext>
             </a:extLst>
           </p:cNvPr>
@@ -10491,7 +10399,7 @@
           <p:cNvPr id="98" name="">
             <a:extLst xmlns:a="http://schemas.openxmlformats.org/drawingml/2006/main">
               <a:ext uri="{FF2B5EF4-FFF2-40B4-BE49-F238E27FC236}">
-                <a16:creationId xmlns:a16="http://schemas.microsoft.com/office/drawing/2014/main" id="{4471EB25-3D3F-4D6D-BF22-EA1B24B3D757}"/>
+                <a16:creationId xmlns:a16="http://schemas.microsoft.com/office/drawing/2014/main" id="{5C2E0277-7EB4-47C5-B9FB-2BA39F56AE3F}"/>
               </a:ext>
             </a:extLst>
           </p:cNvPr>
@@ -10584,7 +10492,7 @@
           <p:cNvPr id="99" name="">
             <a:extLst xmlns:a="http://schemas.openxmlformats.org/drawingml/2006/main">
               <a:ext uri="{FF2B5EF4-FFF2-40B4-BE49-F238E27FC236}">
-                <a16:creationId xmlns:a16="http://schemas.microsoft.com/office/drawing/2014/main" id="{17C897F3-92FA-441A-AE7A-3C12FAF4B153}"/>
+                <a16:creationId xmlns:a16="http://schemas.microsoft.com/office/drawing/2014/main" id="{E57301BC-63EC-4A09-A55B-9E168C8D0602}"/>
               </a:ext>
             </a:extLst>
           </p:cNvPr>
@@ -10650,7 +10558,7 @@
           <p:cNvPr id="100" name="">
             <a:extLst xmlns:a="http://schemas.openxmlformats.org/drawingml/2006/main">
               <a:ext uri="{FF2B5EF4-FFF2-40B4-BE49-F238E27FC236}">
-                <a16:creationId xmlns:a16="http://schemas.microsoft.com/office/drawing/2014/main" id="{4FBDE47E-88E4-4E62-BFF6-BC77D8557D6F}"/>
+                <a16:creationId xmlns:a16="http://schemas.microsoft.com/office/drawing/2014/main" id="{D4E481E8-1F8D-4C0C-8CD1-1B86D2562209}"/>
               </a:ext>
             </a:extLst>
           </p:cNvPr>
@@ -10743,7 +10651,7 @@
           <p:cNvPr id="101" name="">
             <a:extLst xmlns:a="http://schemas.openxmlformats.org/drawingml/2006/main">
               <a:ext uri="{FF2B5EF4-FFF2-40B4-BE49-F238E27FC236}">
-                <a16:creationId xmlns:a16="http://schemas.microsoft.com/office/drawing/2014/main" id="{52EB2712-2958-4DA3-BF14-25D7BDC3F1E1}"/>
+                <a16:creationId xmlns:a16="http://schemas.microsoft.com/office/drawing/2014/main" id="{E53CB478-A662-457E-9B05-78339A55C956}"/>
               </a:ext>
             </a:extLst>
           </p:cNvPr>
@@ -10809,7 +10717,7 @@
           <p:cNvPr id="102" name="">
             <a:extLst xmlns:a="http://schemas.openxmlformats.org/drawingml/2006/main">
               <a:ext uri="{FF2B5EF4-FFF2-40B4-BE49-F238E27FC236}">
-                <a16:creationId xmlns:a16="http://schemas.microsoft.com/office/drawing/2014/main" id="{5507A9DD-59C7-42C0-9DBE-E264F220C4D9}"/>
+                <a16:creationId xmlns:a16="http://schemas.microsoft.com/office/drawing/2014/main" id="{977AF62F-7686-4F93-B760-93F0F3D64D37}"/>
               </a:ext>
             </a:extLst>
           </p:cNvPr>
@@ -10902,7 +10810,7 @@
           <p:cNvPr id="103" name="">
             <a:extLst xmlns:a="http://schemas.openxmlformats.org/drawingml/2006/main">
               <a:ext uri="{FF2B5EF4-FFF2-40B4-BE49-F238E27FC236}">
-                <a16:creationId xmlns:a16="http://schemas.microsoft.com/office/drawing/2014/main" id="{E4C9FD32-058B-463B-8263-6416D78A0019}"/>
+                <a16:creationId xmlns:a16="http://schemas.microsoft.com/office/drawing/2014/main" id="{F9E114D7-85BC-4923-A50D-36AF1670BA7E}"/>
               </a:ext>
             </a:extLst>
           </p:cNvPr>
@@ -10972,7 +10880,7 @@
           <p:cNvPr id="104" name="">
             <a:extLst xmlns:a="http://schemas.openxmlformats.org/drawingml/2006/main">
               <a:ext uri="{FF2B5EF4-FFF2-40B4-BE49-F238E27FC236}">
-                <a16:creationId xmlns:a16="http://schemas.microsoft.com/office/drawing/2014/main" id="{D26F7E4F-270A-4819-817A-68093E36E4A1}"/>
+                <a16:creationId xmlns:a16="http://schemas.microsoft.com/office/drawing/2014/main" id="{8D263288-410A-4712-B506-9FF09598074D}"/>
               </a:ext>
             </a:extLst>
           </p:cNvPr>
@@ -11038,7 +10946,7 @@
           <p:cNvPr id="105" name="">
             <a:extLst xmlns:a="http://schemas.openxmlformats.org/drawingml/2006/main">
               <a:ext uri="{FF2B5EF4-FFF2-40B4-BE49-F238E27FC236}">
-                <a16:creationId xmlns:a16="http://schemas.microsoft.com/office/drawing/2014/main" id="{C3BDAFEE-C750-4B0A-9CBE-B668ACD3E892}"/>
+                <a16:creationId xmlns:a16="http://schemas.microsoft.com/office/drawing/2014/main" id="{8E03E355-BD64-4E54-A26F-C835D9F1D7C1}"/>
               </a:ext>
             </a:extLst>
           </p:cNvPr>
@@ -11108,7 +11016,7 @@
           <p:cNvPr id="106" name="">
             <a:extLst xmlns:a="http://schemas.openxmlformats.org/drawingml/2006/main">
               <a:ext uri="{FF2B5EF4-FFF2-40B4-BE49-F238E27FC236}">
-                <a16:creationId xmlns:a16="http://schemas.microsoft.com/office/drawing/2014/main" id="{E6C485CD-A5C7-43EB-8D9D-CC4696115C3D}"/>
+                <a16:creationId xmlns:a16="http://schemas.microsoft.com/office/drawing/2014/main" id="{59EE3649-B3ED-4700-B90D-FEA38F7CE101}"/>
               </a:ext>
             </a:extLst>
           </p:cNvPr>
@@ -11172,7 +11080,7 @@
     </p:spTree>
     <p:extLst>
       <p:ext uri="{BB962C8B-B14F-4D97-AF65-F5344CB8AC3E}">
-        <p14:creationId xmlns:p14="http://schemas.microsoft.com/office/powerpoint/2010/main" val="172672102"/>
+        <p14:creationId xmlns:p14="http://schemas.microsoft.com/office/powerpoint/2010/main" val="581545842"/>
       </p:ext>
     </p:extLst>
   </p:cSld>
@@ -11196,7 +11104,7 @@
           <p:cNvPr id="100" name="Google Shape;100;p19">
             <a:extLst xmlns:a="http://schemas.openxmlformats.org/drawingml/2006/main">
               <a:ext uri="{FF2B5EF4-FFF2-40B4-BE49-F238E27FC236}">
-                <a16:creationId xmlns:a16="http://schemas.microsoft.com/office/drawing/2014/main" id="{08403958-BC37-486C-9811-F35A1029BE73}"/>
+                <a16:creationId xmlns:a16="http://schemas.microsoft.com/office/drawing/2014/main" id="{7E7F849F-3013-4944-888C-6113205D470D}"/>
               </a:ext>
             </a:extLst>
           </p:cNvPr>
@@ -11206,7 +11114,7 @@
           <p:nvPr/>
         </p:nvPicPr>
         <p:blipFill rotWithShape="1">
-          <a:blip xmlns:r="http://schemas.openxmlformats.org/officeDocument/2006/relationships" xmlns:a="http://schemas.openxmlformats.org/drawingml/2006/main" r:embed="R3a433f0a0a3b488e">
+          <a:blip xmlns:r="http://schemas.openxmlformats.org/officeDocument/2006/relationships" xmlns:a="http://schemas.openxmlformats.org/drawingml/2006/main" r:embed="R1d446917336c47a7">
             <a:alphaModFix/>
           </a:blip>
           <a:srcRect xmlns:a="http://schemas.openxmlformats.org/drawingml/2006/main" l="0" t="0" r="0" b="98001"/>
@@ -11230,7 +11138,7 @@
           <p:cNvPr id="101" name="Google Shape;101;p19">
             <a:extLst xmlns:a="http://schemas.openxmlformats.org/drawingml/2006/main">
               <a:ext uri="{FF2B5EF4-FFF2-40B4-BE49-F238E27FC236}">
-                <a16:creationId xmlns:a16="http://schemas.microsoft.com/office/drawing/2014/main" id="{FDF9B4B7-5247-4A09-9624-F037D38335A5}"/>
+                <a16:creationId xmlns:a16="http://schemas.microsoft.com/office/drawing/2014/main" id="{9CF77DC8-7E39-4974-BF7C-04A7163CC158}"/>
               </a:ext>
             </a:extLst>
           </p:cNvPr>
@@ -11240,7 +11148,7 @@
           <p:nvPr/>
         </p:nvPicPr>
         <p:blipFill>
-          <a:blip xmlns:r="http://schemas.openxmlformats.org/officeDocument/2006/relationships" xmlns:a="http://schemas.openxmlformats.org/drawingml/2006/main" r:embed="R2328ea06624b4f16">
+          <a:blip xmlns:r="http://schemas.openxmlformats.org/officeDocument/2006/relationships" xmlns:a="http://schemas.openxmlformats.org/drawingml/2006/main" r:embed="R9aaf10f0016f4a59">
             <a:alphaModFix/>
           </a:blip>
           <a:stretch xmlns:a="http://schemas.openxmlformats.org/drawingml/2006/main">
@@ -11265,7 +11173,7 @@
           <p:cNvPr id="102" name="Google Shape;102;p19">
             <a:extLst xmlns:a="http://schemas.openxmlformats.org/drawingml/2006/main">
               <a:ext uri="{FF2B5EF4-FFF2-40B4-BE49-F238E27FC236}">
-                <a16:creationId xmlns:a16="http://schemas.microsoft.com/office/drawing/2014/main" id="{733F95B4-387B-48EF-A7B7-B68F2DFB9527}"/>
+                <a16:creationId xmlns:a16="http://schemas.microsoft.com/office/drawing/2014/main" id="{E64F911D-1F8E-43B5-94E1-800C9F9ED349}"/>
               </a:ext>
             </a:extLst>
           </p:cNvPr>
@@ -11316,7 +11224,7 @@
           <p:cNvPr id="103" name="Google Shape;103;p19">
             <a:extLst xmlns:a="http://schemas.openxmlformats.org/drawingml/2006/main">
               <a:ext uri="{FF2B5EF4-FFF2-40B4-BE49-F238E27FC236}">
-                <a16:creationId xmlns:a16="http://schemas.microsoft.com/office/drawing/2014/main" id="{4C5CA4A7-A8BE-4774-A94E-78EB1F6165F8}"/>
+                <a16:creationId xmlns:a16="http://schemas.microsoft.com/office/drawing/2014/main" id="{2F8EFA09-3D0C-44B0-AA63-8BF67C2FE491}"/>
               </a:ext>
             </a:extLst>
           </p:cNvPr>
@@ -11374,7 +11282,7 @@
           <p:cNvPr id="104" name="">
             <a:extLst xmlns:a="http://schemas.openxmlformats.org/drawingml/2006/main">
               <a:ext uri="{FF2B5EF4-FFF2-40B4-BE49-F238E27FC236}">
-                <a16:creationId xmlns:a16="http://schemas.microsoft.com/office/drawing/2014/main" id="{4E4C399F-9607-45C9-A0E3-D0F09C0CC8BC}"/>
+                <a16:creationId xmlns:a16="http://schemas.microsoft.com/office/drawing/2014/main" id="{359CF23A-3725-49B2-805C-50FFA39060B3}"/>
               </a:ext>
             </a:extLst>
           </p:cNvPr>
@@ -11384,7 +11292,7 @@
           <p:nvPr/>
         </p:nvPicPr>
         <p:blipFill>
-          <a:blip xmlns:r="http://schemas.openxmlformats.org/officeDocument/2006/relationships" xmlns:a="http://schemas.openxmlformats.org/drawingml/2006/main" r:embed="R90bbfd4a50a34f6f"/>
+          <a:blip xmlns:r="http://schemas.openxmlformats.org/officeDocument/2006/relationships" xmlns:a="http://schemas.openxmlformats.org/drawingml/2006/main" r:embed="R390669126d894581"/>
           <a:stretch xmlns:a="http://schemas.openxmlformats.org/drawingml/2006/main"/>
         </p:blipFill>
         <p:spPr>
@@ -11400,7 +11308,7 @@
     </p:spTree>
     <p:extLst>
       <p:ext uri="{BB962C8B-B14F-4D97-AF65-F5344CB8AC3E}">
-        <p14:creationId xmlns:p14="http://schemas.microsoft.com/office/powerpoint/2010/main" val="206453289"/>
+        <p14:creationId xmlns:p14="http://schemas.microsoft.com/office/powerpoint/2010/main" val="1380917570"/>
       </p:ext>
     </p:extLst>
   </p:cSld>
@@ -11424,7 +11332,7 @@
           <p:cNvPr id="108" name="Google Shape;108;p20">
             <a:extLst xmlns:a="http://schemas.openxmlformats.org/drawingml/2006/main">
               <a:ext uri="{FF2B5EF4-FFF2-40B4-BE49-F238E27FC236}">
-                <a16:creationId xmlns:a16="http://schemas.microsoft.com/office/drawing/2014/main" id="{78B96099-670D-4356-8B55-0B6C9FC81655}"/>
+                <a16:creationId xmlns:a16="http://schemas.microsoft.com/office/drawing/2014/main" id="{3DDDDDDA-3255-447A-92A0-55CA462A5BEE}"/>
               </a:ext>
             </a:extLst>
           </p:cNvPr>
@@ -11434,7 +11342,7 @@
           <p:nvPr/>
         </p:nvPicPr>
         <p:blipFill rotWithShape="1">
-          <a:blip xmlns:r="http://schemas.openxmlformats.org/officeDocument/2006/relationships" xmlns:a="http://schemas.openxmlformats.org/drawingml/2006/main" r:embed="Rd92e86ae1bb6424e">
+          <a:blip xmlns:r="http://schemas.openxmlformats.org/officeDocument/2006/relationships" xmlns:a="http://schemas.openxmlformats.org/drawingml/2006/main" r:embed="R781ef98f3f31432d">
             <a:alphaModFix/>
           </a:blip>
           <a:srcRect xmlns:a="http://schemas.openxmlformats.org/drawingml/2006/main" l="0" t="0" r="0" b="98001"/>
@@ -11458,7 +11366,7 @@
           <p:cNvPr id="109" name="Google Shape;109;p20">
             <a:extLst xmlns:a="http://schemas.openxmlformats.org/drawingml/2006/main">
               <a:ext uri="{FF2B5EF4-FFF2-40B4-BE49-F238E27FC236}">
-                <a16:creationId xmlns:a16="http://schemas.microsoft.com/office/drawing/2014/main" id="{A55E6E94-03CF-40A2-BDE1-FB6D4AF49C4B}"/>
+                <a16:creationId xmlns:a16="http://schemas.microsoft.com/office/drawing/2014/main" id="{458520B6-315F-41C5-B9A3-3E3267B7A879}"/>
               </a:ext>
             </a:extLst>
           </p:cNvPr>
@@ -11468,7 +11376,7 @@
           <p:nvPr/>
         </p:nvPicPr>
         <p:blipFill>
-          <a:blip xmlns:r="http://schemas.openxmlformats.org/officeDocument/2006/relationships" xmlns:a="http://schemas.openxmlformats.org/drawingml/2006/main" r:embed="R3ff2675f46494e8e">
+          <a:blip xmlns:r="http://schemas.openxmlformats.org/officeDocument/2006/relationships" xmlns:a="http://schemas.openxmlformats.org/drawingml/2006/main" r:embed="Rb5defc6dcb4242a6">
             <a:alphaModFix/>
           </a:blip>
           <a:stretch xmlns:a="http://schemas.openxmlformats.org/drawingml/2006/main">
@@ -11493,7 +11401,7 @@
           <p:cNvPr id="110" name="Google Shape;110;p20">
             <a:extLst xmlns:a="http://schemas.openxmlformats.org/drawingml/2006/main">
               <a:ext uri="{FF2B5EF4-FFF2-40B4-BE49-F238E27FC236}">
-                <a16:creationId xmlns:a16="http://schemas.microsoft.com/office/drawing/2014/main" id="{9EB7986B-69D5-4593-BD56-2A650F4C295C}"/>
+                <a16:creationId xmlns:a16="http://schemas.microsoft.com/office/drawing/2014/main" id="{6777ECCE-8201-4467-90BA-9B4D58FF20A7}"/>
               </a:ext>
             </a:extLst>
           </p:cNvPr>
@@ -11544,7 +11452,7 @@
           <p:cNvPr id="111" name="Google Shape;111;p20">
             <a:extLst xmlns:a="http://schemas.openxmlformats.org/drawingml/2006/main">
               <a:ext uri="{FF2B5EF4-FFF2-40B4-BE49-F238E27FC236}">
-                <a16:creationId xmlns:a16="http://schemas.microsoft.com/office/drawing/2014/main" id="{0FBE3D24-A853-41B8-8000-E71E217EEC7B}"/>
+                <a16:creationId xmlns:a16="http://schemas.microsoft.com/office/drawing/2014/main" id="{E4446E3D-3F5B-450B-95B6-C6E99B85E7D9}"/>
               </a:ext>
             </a:extLst>
           </p:cNvPr>
@@ -11602,7 +11510,7 @@
           <p:cNvPr id="112" name="">
             <a:extLst xmlns:a="http://schemas.openxmlformats.org/drawingml/2006/main">
               <a:ext uri="{FF2B5EF4-FFF2-40B4-BE49-F238E27FC236}">
-                <a16:creationId xmlns:a16="http://schemas.microsoft.com/office/drawing/2014/main" id="{AFFD4348-10A7-4426-8438-B3523C45BEC5}"/>
+                <a16:creationId xmlns:a16="http://schemas.microsoft.com/office/drawing/2014/main" id="{FB3A79B0-BC6C-49C7-BA60-7E2E03623FB8}"/>
               </a:ext>
             </a:extLst>
           </p:cNvPr>
@@ -11672,7 +11580,7 @@
           <p:cNvPr id="113" name="">
             <a:extLst xmlns:a="http://schemas.openxmlformats.org/drawingml/2006/main">
               <a:ext uri="{FF2B5EF4-FFF2-40B4-BE49-F238E27FC236}">
-                <a16:creationId xmlns:a16="http://schemas.microsoft.com/office/drawing/2014/main" id="{9B55927F-1567-4864-BCAD-8311A904D534}"/>
+                <a16:creationId xmlns:a16="http://schemas.microsoft.com/office/drawing/2014/main" id="{CD772595-BCC9-429D-8D2E-56FC5E15B988}"/>
               </a:ext>
             </a:extLst>
           </p:cNvPr>
@@ -11738,7 +11646,7 @@
           <p:cNvPr id="114" name="">
             <a:extLst xmlns:a="http://schemas.openxmlformats.org/drawingml/2006/main">
               <a:ext uri="{FF2B5EF4-FFF2-40B4-BE49-F238E27FC236}">
-                <a16:creationId xmlns:a16="http://schemas.microsoft.com/office/drawing/2014/main" id="{B99900C0-15D6-4579-9D82-23E91C975BF9}"/>
+                <a16:creationId xmlns:a16="http://schemas.microsoft.com/office/drawing/2014/main" id="{B43840A1-AA20-4BC9-BF46-427A92F0D02F}"/>
               </a:ext>
             </a:extLst>
           </p:cNvPr>
@@ -11808,7 +11716,7 @@
           <p:cNvPr id="115" name="">
             <a:extLst xmlns:a="http://schemas.openxmlformats.org/drawingml/2006/main">
               <a:ext uri="{FF2B5EF4-FFF2-40B4-BE49-F238E27FC236}">
-                <a16:creationId xmlns:a16="http://schemas.microsoft.com/office/drawing/2014/main" id="{4D7421EF-A3DA-4962-9966-70FA18AEFD52}"/>
+                <a16:creationId xmlns:a16="http://schemas.microsoft.com/office/drawing/2014/main" id="{6F588C79-5DAB-415A-B732-DE00FE08F75A}"/>
               </a:ext>
             </a:extLst>
           </p:cNvPr>
@@ -11874,7 +11782,7 @@
           <p:cNvPr id="116" name="">
             <a:extLst xmlns:a="http://schemas.openxmlformats.org/drawingml/2006/main">
               <a:ext uri="{FF2B5EF4-FFF2-40B4-BE49-F238E27FC236}">
-                <a16:creationId xmlns:a16="http://schemas.microsoft.com/office/drawing/2014/main" id="{A709EA28-A559-4CFA-BF96-FB81D2C18970}"/>
+                <a16:creationId xmlns:a16="http://schemas.microsoft.com/office/drawing/2014/main" id="{6F962106-B494-482C-B730-4013EE1021A8}"/>
               </a:ext>
             </a:extLst>
           </p:cNvPr>
@@ -11944,7 +11852,7 @@
           <p:cNvPr id="117" name="">
             <a:extLst xmlns:a="http://schemas.openxmlformats.org/drawingml/2006/main">
               <a:ext uri="{FF2B5EF4-FFF2-40B4-BE49-F238E27FC236}">
-                <a16:creationId xmlns:a16="http://schemas.microsoft.com/office/drawing/2014/main" id="{E3463DF0-082C-402B-9223-9008A38DBF20}"/>
+                <a16:creationId xmlns:a16="http://schemas.microsoft.com/office/drawing/2014/main" id="{5A997987-81DD-4DC5-9698-9C82F657C598}"/>
               </a:ext>
             </a:extLst>
           </p:cNvPr>
@@ -12014,7 +11922,7 @@
           <p:cNvPr id="118" name="">
             <a:extLst xmlns:a="http://schemas.openxmlformats.org/drawingml/2006/main">
               <a:ext uri="{FF2B5EF4-FFF2-40B4-BE49-F238E27FC236}">
-                <a16:creationId xmlns:a16="http://schemas.microsoft.com/office/drawing/2014/main" id="{D4862278-BFE8-4598-B117-FE12D891B3E5}"/>
+                <a16:creationId xmlns:a16="http://schemas.microsoft.com/office/drawing/2014/main" id="{DACB1332-8289-4384-B780-D1E44356EF6E}"/>
               </a:ext>
             </a:extLst>
           </p:cNvPr>
@@ -12080,7 +11988,7 @@
           <p:cNvPr id="119" name="">
             <a:extLst xmlns:a="http://schemas.openxmlformats.org/drawingml/2006/main">
               <a:ext uri="{FF2B5EF4-FFF2-40B4-BE49-F238E27FC236}">
-                <a16:creationId xmlns:a16="http://schemas.microsoft.com/office/drawing/2014/main" id="{6CDE8F39-61CF-4643-B610-128FC5275CA2}"/>
+                <a16:creationId xmlns:a16="http://schemas.microsoft.com/office/drawing/2014/main" id="{DD845FF8-37D7-4541-BACD-9AF7780FF413}"/>
               </a:ext>
             </a:extLst>
           </p:cNvPr>
@@ -12146,7 +12054,7 @@
           <p:cNvPr id="120" name="">
             <a:extLst xmlns:a="http://schemas.openxmlformats.org/drawingml/2006/main">
               <a:ext uri="{FF2B5EF4-FFF2-40B4-BE49-F238E27FC236}">
-                <a16:creationId xmlns:a16="http://schemas.microsoft.com/office/drawing/2014/main" id="{EBB612D5-4020-43A0-B7CB-D5D4F6F3F62F}"/>
+                <a16:creationId xmlns:a16="http://schemas.microsoft.com/office/drawing/2014/main" id="{7D9C2CAB-DE90-431A-B55F-3BAC6C2231D6}"/>
               </a:ext>
             </a:extLst>
           </p:cNvPr>
@@ -12216,7 +12124,7 @@
           <p:cNvPr id="121" name="">
             <a:extLst xmlns:a="http://schemas.openxmlformats.org/drawingml/2006/main">
               <a:ext uri="{FF2B5EF4-FFF2-40B4-BE49-F238E27FC236}">
-                <a16:creationId xmlns:a16="http://schemas.microsoft.com/office/drawing/2014/main" id="{198A1859-CE0A-4780-9614-ECFFFB77E0FF}"/>
+                <a16:creationId xmlns:a16="http://schemas.microsoft.com/office/drawing/2014/main" id="{EC8F05A2-0F17-4646-B6A4-55B34648482C}"/>
               </a:ext>
             </a:extLst>
           </p:cNvPr>
@@ -12309,7 +12217,7 @@
           <p:cNvPr id="122" name="">
             <a:extLst xmlns:a="http://schemas.openxmlformats.org/drawingml/2006/main">
               <a:ext uri="{FF2B5EF4-FFF2-40B4-BE49-F238E27FC236}">
-                <a16:creationId xmlns:a16="http://schemas.microsoft.com/office/drawing/2014/main" id="{1FD439AA-9648-4FEE-A903-59BA648DE719}"/>
+                <a16:creationId xmlns:a16="http://schemas.microsoft.com/office/drawing/2014/main" id="{CC1BF9C0-03C7-4E70-8569-3BEE5F6D38E4}"/>
               </a:ext>
             </a:extLst>
           </p:cNvPr>
@@ -12375,7 +12283,7 @@
           <p:cNvPr id="123" name="">
             <a:extLst xmlns:a="http://schemas.openxmlformats.org/drawingml/2006/main">
               <a:ext uri="{FF2B5EF4-FFF2-40B4-BE49-F238E27FC236}">
-                <a16:creationId xmlns:a16="http://schemas.microsoft.com/office/drawing/2014/main" id="{0ABCA379-05C5-41F3-976C-3226750F757B}"/>
+                <a16:creationId xmlns:a16="http://schemas.microsoft.com/office/drawing/2014/main" id="{25C3DADD-DBD4-4B3C-A22F-3028E6883D10}"/>
               </a:ext>
             </a:extLst>
           </p:cNvPr>
@@ -12468,7 +12376,7 @@
           <p:cNvPr id="124" name="">
             <a:extLst xmlns:a="http://schemas.openxmlformats.org/drawingml/2006/main">
               <a:ext uri="{FF2B5EF4-FFF2-40B4-BE49-F238E27FC236}">
-                <a16:creationId xmlns:a16="http://schemas.microsoft.com/office/drawing/2014/main" id="{470114AE-FD23-44B6-9F48-2C824F183074}"/>
+                <a16:creationId xmlns:a16="http://schemas.microsoft.com/office/drawing/2014/main" id="{3853483F-1C01-46C2-A1A5-12CF06D0F25D}"/>
               </a:ext>
             </a:extLst>
           </p:cNvPr>
@@ -12534,7 +12442,7 @@
           <p:cNvPr id="125" name="">
             <a:extLst xmlns:a="http://schemas.openxmlformats.org/drawingml/2006/main">
               <a:ext uri="{FF2B5EF4-FFF2-40B4-BE49-F238E27FC236}">
-                <a16:creationId xmlns:a16="http://schemas.microsoft.com/office/drawing/2014/main" id="{09A99405-D291-48F2-BC10-522A81ABC3A9}"/>
+                <a16:creationId xmlns:a16="http://schemas.microsoft.com/office/drawing/2014/main" id="{BE4FE2DA-798E-4633-B76C-4991F9BE5A57}"/>
               </a:ext>
             </a:extLst>
           </p:cNvPr>
@@ -12598,7 +12506,7 @@
     </p:spTree>
     <p:extLst>
       <p:ext uri="{BB962C8B-B14F-4D97-AF65-F5344CB8AC3E}">
-        <p14:creationId xmlns:p14="http://schemas.microsoft.com/office/powerpoint/2010/main" val="1034215542"/>
+        <p14:creationId xmlns:p14="http://schemas.microsoft.com/office/powerpoint/2010/main" val="755674555"/>
       </p:ext>
     </p:extLst>
   </p:cSld>
@@ -12622,7 +12530,7 @@
           <p:cNvPr id="116" name="Google Shape;116;p21">
             <a:extLst xmlns:a="http://schemas.openxmlformats.org/drawingml/2006/main">
               <a:ext uri="{FF2B5EF4-FFF2-40B4-BE49-F238E27FC236}">
-                <a16:creationId xmlns:a16="http://schemas.microsoft.com/office/drawing/2014/main" id="{B04E4561-06EC-4749-9795-58043270C803}"/>
+                <a16:creationId xmlns:a16="http://schemas.microsoft.com/office/drawing/2014/main" id="{C45280AE-71F4-460E-8485-A869D15DF885}"/>
               </a:ext>
             </a:extLst>
           </p:cNvPr>
@@ -12632,7 +12540,7 @@
           <p:nvPr/>
         </p:nvPicPr>
         <p:blipFill rotWithShape="1">
-          <a:blip xmlns:r="http://schemas.openxmlformats.org/officeDocument/2006/relationships" xmlns:a="http://schemas.openxmlformats.org/drawingml/2006/main" r:embed="Re1ac525786d94c14">
+          <a:blip xmlns:r="http://schemas.openxmlformats.org/officeDocument/2006/relationships" xmlns:a="http://schemas.openxmlformats.org/drawingml/2006/main" r:embed="R96131a907a4f4a81">
             <a:alphaModFix/>
           </a:blip>
           <a:srcRect xmlns:a="http://schemas.openxmlformats.org/drawingml/2006/main" l="0" t="0" r="0" b="98001"/>
@@ -12656,7 +12564,7 @@
           <p:cNvPr id="117" name="Google Shape;117;p21">
             <a:extLst xmlns:a="http://schemas.openxmlformats.org/drawingml/2006/main">
               <a:ext uri="{FF2B5EF4-FFF2-40B4-BE49-F238E27FC236}">
-                <a16:creationId xmlns:a16="http://schemas.microsoft.com/office/drawing/2014/main" id="{E4ED6FF2-C5EF-4161-AF5C-97CBFF694D1C}"/>
+                <a16:creationId xmlns:a16="http://schemas.microsoft.com/office/drawing/2014/main" id="{4B373DB7-0DF8-4941-898D-8CE5CBEE5077}"/>
               </a:ext>
             </a:extLst>
           </p:cNvPr>
@@ -12666,7 +12574,7 @@
           <p:nvPr/>
         </p:nvPicPr>
         <p:blipFill>
-          <a:blip xmlns:r="http://schemas.openxmlformats.org/officeDocument/2006/relationships" xmlns:a="http://schemas.openxmlformats.org/drawingml/2006/main" r:embed="R29a34d9e34ef4816">
+          <a:blip xmlns:r="http://schemas.openxmlformats.org/officeDocument/2006/relationships" xmlns:a="http://schemas.openxmlformats.org/drawingml/2006/main" r:embed="R43de062007074d90">
             <a:alphaModFix/>
           </a:blip>
           <a:stretch xmlns:a="http://schemas.openxmlformats.org/drawingml/2006/main">
@@ -12691,7 +12599,7 @@
           <p:cNvPr id="118" name="Google Shape;118;p21">
             <a:extLst xmlns:a="http://schemas.openxmlformats.org/drawingml/2006/main">
               <a:ext uri="{FF2B5EF4-FFF2-40B4-BE49-F238E27FC236}">
-                <a16:creationId xmlns:a16="http://schemas.microsoft.com/office/drawing/2014/main" id="{69EF3E56-6AC6-42C2-9FFF-7D45746080B7}"/>
+                <a16:creationId xmlns:a16="http://schemas.microsoft.com/office/drawing/2014/main" id="{AD8A889E-6DD2-40CE-A9C5-65C97031FC85}"/>
               </a:ext>
             </a:extLst>
           </p:cNvPr>
@@ -12742,7 +12650,7 @@
           <p:cNvPr id="119" name="Google Shape;119;p21">
             <a:extLst xmlns:a="http://schemas.openxmlformats.org/drawingml/2006/main">
               <a:ext uri="{FF2B5EF4-FFF2-40B4-BE49-F238E27FC236}">
-                <a16:creationId xmlns:a16="http://schemas.microsoft.com/office/drawing/2014/main" id="{9DA4804E-00D3-4516-8A49-FD5026CD69B0}"/>
+                <a16:creationId xmlns:a16="http://schemas.microsoft.com/office/drawing/2014/main" id="{7C5D7F01-681E-42F3-A4E1-A7BC69E94A82}"/>
               </a:ext>
             </a:extLst>
           </p:cNvPr>
@@ -12800,7 +12708,7 @@
           <p:cNvPr id="120" name="">
             <a:extLst xmlns:a="http://schemas.openxmlformats.org/drawingml/2006/main">
               <a:ext uri="{FF2B5EF4-FFF2-40B4-BE49-F238E27FC236}">
-                <a16:creationId xmlns:a16="http://schemas.microsoft.com/office/drawing/2014/main" id="{1F1750CF-C1CE-486E-9889-1744F3644C26}"/>
+                <a16:creationId xmlns:a16="http://schemas.microsoft.com/office/drawing/2014/main" id="{D0E3BE32-6EAE-41F0-8E07-67850650AADE}"/>
               </a:ext>
             </a:extLst>
           </p:cNvPr>
@@ -12979,7 +12887,7 @@
     </p:spTree>
     <p:extLst>
       <p:ext uri="{BB962C8B-B14F-4D97-AF65-F5344CB8AC3E}">
-        <p14:creationId xmlns:p14="http://schemas.microsoft.com/office/powerpoint/2010/main" val="618524970"/>
+        <p14:creationId xmlns:p14="http://schemas.microsoft.com/office/powerpoint/2010/main" val="537275838"/>
       </p:ext>
     </p:extLst>
   </p:cSld>
@@ -13003,7 +12911,7 @@
           <p:cNvPr id="124" name="Google Shape;124;p22">
             <a:extLst xmlns:a="http://schemas.openxmlformats.org/drawingml/2006/main">
               <a:ext uri="{FF2B5EF4-FFF2-40B4-BE49-F238E27FC236}">
-                <a16:creationId xmlns:a16="http://schemas.microsoft.com/office/drawing/2014/main" id="{0FA702DA-D1AC-43E8-8E11-CDBF7592E0E4}"/>
+                <a16:creationId xmlns:a16="http://schemas.microsoft.com/office/drawing/2014/main" id="{D180ABA5-4AB4-4E37-965A-E794960B1D5D}"/>
               </a:ext>
             </a:extLst>
           </p:cNvPr>
@@ -13013,7 +12921,7 @@
           <p:nvPr/>
         </p:nvPicPr>
         <p:blipFill rotWithShape="1">
-          <a:blip xmlns:r="http://schemas.openxmlformats.org/officeDocument/2006/relationships" xmlns:a="http://schemas.openxmlformats.org/drawingml/2006/main" r:embed="R9b4e3d23294743dd">
+          <a:blip xmlns:r="http://schemas.openxmlformats.org/officeDocument/2006/relationships" xmlns:a="http://schemas.openxmlformats.org/drawingml/2006/main" r:embed="R76589d1cdffa46bb">
             <a:alphaModFix/>
           </a:blip>
           <a:srcRect xmlns:a="http://schemas.openxmlformats.org/drawingml/2006/main" l="0" t="0" r="0" b="98001"/>
@@ -13037,7 +12945,7 @@
           <p:cNvPr id="125" name="Google Shape;125;p22">
             <a:extLst xmlns:a="http://schemas.openxmlformats.org/drawingml/2006/main">
               <a:ext uri="{FF2B5EF4-FFF2-40B4-BE49-F238E27FC236}">
-                <a16:creationId xmlns:a16="http://schemas.microsoft.com/office/drawing/2014/main" id="{50BAE55C-960A-418F-B510-4B3A41C16422}"/>
+                <a16:creationId xmlns:a16="http://schemas.microsoft.com/office/drawing/2014/main" id="{EB2CD9AE-7A00-4654-A5F0-58685A104DAA}"/>
               </a:ext>
             </a:extLst>
           </p:cNvPr>
@@ -13047,7 +12955,7 @@
           <p:nvPr/>
         </p:nvPicPr>
         <p:blipFill>
-          <a:blip xmlns:r="http://schemas.openxmlformats.org/officeDocument/2006/relationships" xmlns:a="http://schemas.openxmlformats.org/drawingml/2006/main" r:embed="Re8f0304cdf9f4a9d">
+          <a:blip xmlns:r="http://schemas.openxmlformats.org/officeDocument/2006/relationships" xmlns:a="http://schemas.openxmlformats.org/drawingml/2006/main" r:embed="R5666b9db912e4b99">
             <a:alphaModFix/>
           </a:blip>
           <a:stretch xmlns:a="http://schemas.openxmlformats.org/drawingml/2006/main">
@@ -13072,7 +12980,7 @@
           <p:cNvPr id="126" name="Google Shape;126;p22">
             <a:extLst xmlns:a="http://schemas.openxmlformats.org/drawingml/2006/main">
               <a:ext uri="{FF2B5EF4-FFF2-40B4-BE49-F238E27FC236}">
-                <a16:creationId xmlns:a16="http://schemas.microsoft.com/office/drawing/2014/main" id="{C179A843-419A-4A0D-A8BF-B2784CB61A3A}"/>
+                <a16:creationId xmlns:a16="http://schemas.microsoft.com/office/drawing/2014/main" id="{DA72AEAF-4B66-46BD-895D-AB5A8FE38505}"/>
               </a:ext>
             </a:extLst>
           </p:cNvPr>
@@ -13123,7 +13031,7 @@
           <p:cNvPr id="127" name="Google Shape;127;p22">
             <a:extLst xmlns:a="http://schemas.openxmlformats.org/drawingml/2006/main">
               <a:ext uri="{FF2B5EF4-FFF2-40B4-BE49-F238E27FC236}">
-                <a16:creationId xmlns:a16="http://schemas.microsoft.com/office/drawing/2014/main" id="{52F2283C-8847-4311-8C9D-8039789C926D}"/>
+                <a16:creationId xmlns:a16="http://schemas.microsoft.com/office/drawing/2014/main" id="{86A9A23D-4461-4C89-A985-7C89DAEF87A9}"/>
               </a:ext>
             </a:extLst>
           </p:cNvPr>
@@ -13181,7 +13089,7 @@
           <p:cNvPr id="128" name="">
             <a:extLst xmlns:a="http://schemas.openxmlformats.org/drawingml/2006/main">
               <a:ext uri="{FF2B5EF4-FFF2-40B4-BE49-F238E27FC236}">
-                <a16:creationId xmlns:a16="http://schemas.microsoft.com/office/drawing/2014/main" id="{97C79190-F72A-42AD-8750-229C94982BEB}"/>
+                <a16:creationId xmlns:a16="http://schemas.microsoft.com/office/drawing/2014/main" id="{5098DA3D-D247-4202-A364-E18BF6E07B7A}"/>
               </a:ext>
             </a:extLst>
           </p:cNvPr>
@@ -13207,7 +13115,7 @@
           <a:bodyPr xmlns:a="http://schemas.openxmlformats.org/drawingml/2006/main"/>
           <a:lstStyle xmlns:a="http://schemas.openxmlformats.org/drawingml/2006/main">
             <a:defPPr>
-              <a:defRPr sz="1800" b="0">
+              <a:defRPr sz="1725" b="0">
                 <a:solidFill>
                   <a:srgbClr val="202124"/>
                 </a:solidFill>
@@ -13219,7 +13127,7 @@
           </a:lstStyle>
           <a:p xmlns:a="http://schemas.openxmlformats.org/drawingml/2006/main">
             <a:pPr>
-              <a:defRPr sz="1800" b="0">
+              <a:defRPr sz="1725" b="0">
                 <a:solidFill>
                   <a:srgbClr val="202124"/>
                 </a:solidFill>
@@ -13229,7 +13137,7 @@
               </a:defRPr>
             </a:pPr>
             <a:r>
-              <a:rPr sz="1800" b="0">
+              <a:rPr sz="1725" b="0">
                 <a:solidFill>
                   <a:srgbClr val="202124"/>
                 </a:solidFill>
@@ -13247,7 +13155,7 @@
           </a:p>
           <a:p xmlns:a="http://schemas.openxmlformats.org/drawingml/2006/main">
             <a:pPr>
-              <a:defRPr sz="1800" b="0">
+              <a:defRPr sz="1725" b="0">
                 <a:solidFill>
                   <a:srgbClr val="202124"/>
                 </a:solidFill>
@@ -13257,7 +13165,7 @@
               </a:defRPr>
             </a:pPr>
             <a:r>
-              <a:rPr sz="1800" b="0">
+              <a:rPr sz="1725" b="0">
                 <a:solidFill>
                   <a:srgbClr val="202124"/>
                 </a:solidFill>
@@ -13265,7 +13173,7 @@
                 <a:ea typeface="Google Sans Flex Medium"/>
                 <a:cs typeface="Google Sans Flex Medium"/>
               </a:rPr>
-              <a:t>Four selected completed local runs: estimated model-token cost US$0.0711, before search, Vision, infrastructure and failed attempts. This is not a billing receipt.</a:t>
+              <a:t>Twelve-case development evaluation: US$0.994 working estimate, including conservative failed-attempt reserves. Not a billing receipt; some infrastructure costs excluded.</a:t>
             </a:r>
           </a:p>
           <a:p xmlns:a="http://schemas.openxmlformats.org/drawingml/2006/main">
@@ -13275,7 +13183,7 @@
           </a:p>
           <a:p xmlns:a="http://schemas.openxmlformats.org/drawingml/2006/main">
             <a:pPr>
-              <a:defRPr sz="1800" b="0">
+              <a:defRPr sz="1725" b="0">
                 <a:solidFill>
                   <a:srgbClr val="202124"/>
                 </a:solidFill>
@@ -13285,7 +13193,7 @@
               </a:defRPr>
             </a:pPr>
             <a:r>
-              <a:rPr sz="1800" b="0">
+              <a:rPr sz="1725" b="0">
                 <a:solidFill>
                   <a:srgbClr val="202124"/>
                 </a:solidFill>
@@ -13293,7 +13201,7 @@
                 <a:ea typeface="Google Sans Flex Medium"/>
                 <a:cs typeface="Google Sans Flex Medium"/>
               </a:rPr>
-              <a:t>Controls: zero minimum / one maximum instance; four new attempts per day and twelve across the live window.</a:t>
+              <a:t>Controls: zero minimum / one maximum instance; four admissions per UTC day and twelve across the live window, with six reserved for reviewers.</a:t>
             </a:r>
           </a:p>
           <a:p xmlns:a="http://schemas.openxmlformats.org/drawingml/2006/main">
@@ -13303,7 +13211,7 @@
           </a:p>
           <a:p xmlns:a="http://schemas.openxmlformats.org/drawingml/2006/main">
             <a:pPr>
-              <a:defRPr sz="1800" b="0">
+              <a:defRPr sz="1725" b="0">
                 <a:solidFill>
                   <a:srgbClr val="202124"/>
                 </a:solidFill>
@@ -13313,7 +13221,7 @@
               </a:defRPr>
             </a:pPr>
             <a:r>
-              <a:rPr sz="1800" b="0">
+              <a:rPr sz="1725" b="0">
                 <a:solidFill>
                   <a:srgbClr val="202124"/>
                 </a:solidFill>
@@ -13329,7 +13237,7 @@
     </p:spTree>
     <p:extLst>
       <p:ext uri="{BB962C8B-B14F-4D97-AF65-F5344CB8AC3E}">
-        <p14:creationId xmlns:p14="http://schemas.microsoft.com/office/powerpoint/2010/main" val="915584863"/>
+        <p14:creationId xmlns:p14="http://schemas.microsoft.com/office/powerpoint/2010/main" val="1904280824"/>
       </p:ext>
     </p:extLst>
   </p:cSld>

</xml_diff>